<commit_message>
deck: add shape-of-output, design-validation failure, genome correction, simulation readiness, flight elimination, glide bound, sequence results; fix a CSS bug that meant no bar ever rendered; 10 numbers corrected against source
Co-Authored-By: Claude Opus 5 <noreply@anthropic.com>
</commit_message>
<xml_diff>
--- a/dashboard/public/deck/delphi-pitch.pptx
+++ b/dashboard/public/deck/delphi-pitch.pptx
@@ -1256,9 +1256,9 @@
           </c:spPr>
           <c:cat>
             <c:strRef>
-              <c:f>Sheet1!$A$2:$A$5</c:f>
+              <c:f>Sheet1!$A$2:$A$8</c:f>
               <c:strCache>
-                <c:ptCount val="4"/>
+                <c:ptCount val="7"/>
                 <c:pt idx="0">
                   <c:v>Proofs + assessments</c:v>
                 </c:pt>
@@ -1271,15 +1271,24 @@
                 <c:pt idx="3">
                   <c:v>Claim tests, incl. refutations</c:v>
                 </c:pt>
+                <c:pt idx="4">
+                  <c:v>Gene-to-fin, mostly negative</c:v>
+                </c:pt>
+                <c:pt idx="5">
+                  <c:v>The held-out exam</c:v>
+                </c:pt>
+                <c:pt idx="6">
+                  <c:v>Flight physics</c:v>
+                </c:pt>
               </c:strCache>
             </c:strRef>
           </c:cat>
           <c:val>
             <c:numRef>
-              <c:f>Sheet1!$B$2:$B$5</c:f>
+              <c:f>Sheet1!$B$2:$B$8</c:f>
               <c:numCache>
                 <c:formatCode>General</c:formatCode>
-                <c:ptCount val="4"/>
+                <c:ptCount val="7"/>
                 <c:pt idx="0">
                   <c:v>55</c:v>
                 </c:pt>
@@ -1291,6 +1300,15 @@
                 </c:pt>
                 <c:pt idx="3">
                   <c:v>15</c:v>
+                </c:pt>
+                <c:pt idx="4">
+                  <c:v>21</c:v>
+                </c:pt>
+                <c:pt idx="5">
+                  <c:v>10</c:v>
+                </c:pt>
+                <c:pt idx="6">
+                  <c:v>13</c:v>
                 </c:pt>
               </c:numCache>
             </c:numRef>
@@ -9968,7 +9986,7 @@
                 </a:solidFill>
                 <a:latin typeface="Segoe UI"/>
               </a:rPr>
-              <a:t>357 named pieces. One measured proportion.</a:t>
+              <a:t>357 named pieces. 23 measured numbers behind them.</a:t>
             </a:r>
           </a:p>
         </p:txBody>
@@ -10041,7 +10059,7 @@
                 </a:solidFill>
                 <a:latin typeface="Segoe UI"/>
               </a:rPr>
-              <a:t>Evidence-backed: exactly one proportion — pectoral fin length at 0.687 of standard length, the median of 49 museum specimens, read from the measurement file rather than typed in (preserved museum specimens; length only (no fin area, shape or spread)).   Schematic, and labelled so per piece: everything else, including every count.   Where the ontology ran out: 60 of the flying fish's pieces have no ontology term at all; the manifest records a null and the nearest ancestor it could find instead of inventing one.</a:t>
+              <a:t>Evidence-backed: the flying fish rests on exactly ONE measured proportion — pectoral fin length at 0.687 of standard length, the median of 49 museum specimens, read from the measurement file rather than typed in (preserved museum specimens; length only (no fin area, shape or spread)). The two zebrafish models carry 22 sourced proportions and counts between them.   Schematic, and labelled so per piece: everything else, including every count.   Where the ontology ran out: 60 of the flying fish's pieces have no ontology term at all; the manifest records a null and the nearest ancestor it could find, instead of inventing one.</a:t>
             </a:r>
           </a:p>
         </p:txBody>
@@ -11602,7 +11620,7 @@
                 </a:solidFill>
                 <a:latin typeface="Segoe UI"/>
               </a:rPr>
-              <a:t>114 records drafted and validated</a:t>
+              <a:t>158 records drafted and validated</a:t>
             </a:r>
           </a:p>
         </p:txBody>
@@ -13830,7 +13848,7 @@
                 </a:solidFill>
                 <a:latin typeface="Segoe UI"/>
               </a:rPr>
-              <a:t>Four changes. No usable shortcut.</a:t>
+              <a:t>Six changes. No usable shortcut.</a:t>
             </a:r>
           </a:p>
         </p:txBody>

</xml_diff>

<commit_message>
deck: state both aerobic ceilings explicitly (0.0357 W committed proxies, 38x; 0.0458 W envelope over measured teleost ranges, 29x) read from lean/empirical.json; flight slide restructured, PPTX split to 25
Co-Authored-By: Claude Opus 5 <noreply@anthropic.com>
</commit_message>
<xml_diff>
--- a/dashboard/public/deck/delphi-pitch.pptx
+++ b/dashboard/public/deck/delphi-pitch.pptx
@@ -29,6 +29,7 @@
     <p:sldId id="277" r:id="rId28"/>
     <p:sldId id="278" r:id="rId29"/>
     <p:sldId id="279" r:id="rId30"/>
+    <p:sldId id="280" r:id="rId31"/>
   </p:sldIdLst>
   <p:sldSz cx="12191695" cy="6858000" type="screen4x3"/>
   <p:notesSz cx="6858000" cy="9144000"/>
@@ -6608,7 +6609,9 @@
           </a:fontRef>
         </p:style>
         <p:txBody>
-          <a:bodyPr rtlCol="0" anchor="ctr" wrap="square"/>
+          <a:bodyPr rtlCol="0" anchor="ctr" wrap="square">
+            <a:spAutoFit/>
+          </a:bodyPr>
           <a:lstStyle/>
           <a:p>
             <a:pPr algn="ctr"/>
@@ -6876,7 +6879,9 @@
           </a:fontRef>
         </p:style>
         <p:txBody>
-          <a:bodyPr rtlCol="0" anchor="ctr" wrap="square"/>
+          <a:bodyPr rtlCol="0" anchor="ctr" wrap="square">
+            <a:spAutoFit/>
+          </a:bodyPr>
           <a:lstStyle/>
           <a:p>
             <a:pPr algn="ctr"/>
@@ -7713,7 +7718,9 @@
           </a:fontRef>
         </p:style>
         <p:txBody>
-          <a:bodyPr rtlCol="0" anchor="ctr" wrap="square"/>
+          <a:bodyPr rtlCol="0" anchor="ctr" wrap="square">
+            <a:spAutoFit/>
+          </a:bodyPr>
           <a:lstStyle/>
           <a:p>
             <a:pPr algn="ctr"/>
@@ -8399,7 +8406,7 @@
         </p:nvSpPr>
         <p:spPr>
           <a:xfrm>
-            <a:off x="713232" y="2103120"/>
+            <a:off x="713232" y="2057400"/>
             <a:ext cx="2834640" cy="1280160"/>
           </a:xfrm>
           <a:prstGeom prst="rect">
@@ -8438,7 +8445,7 @@
         </p:nvSpPr>
         <p:spPr>
           <a:xfrm>
-            <a:off x="713232" y="3246120"/>
+            <a:off x="713232" y="3200400"/>
             <a:ext cx="2834640" cy="1005840"/>
           </a:xfrm>
           <a:prstGeom prst="rect">
@@ -8464,7 +8471,7 @@
                 </a:solidFill>
                 <a:latin typeface="Segoe UI"/>
               </a:rPr>
-              <a:t>aerobic mechanical ceiling the oxygen budget can pay for</a:t>
+              <a:t>aerobic ceiling on the proxy values we commit to</a:t>
             </a:r>
           </a:p>
         </p:txBody>
@@ -8477,7 +8484,7 @@
         </p:nvSpPr>
         <p:spPr>
           <a:xfrm>
-            <a:off x="3913632" y="2103120"/>
+            <a:off x="3913632" y="2057400"/>
             <a:ext cx="2834640" cy="1280160"/>
           </a:xfrm>
           <a:prstGeom prst="rect">
@@ -8516,7 +8523,7 @@
         </p:nvSpPr>
         <p:spPr>
           <a:xfrm>
-            <a:off x="3913632" y="3246120"/>
+            <a:off x="3913632" y="3200400"/>
             <a:ext cx="2834640" cy="1005840"/>
           </a:xfrm>
           <a:prstGeom prst="rect">
@@ -8555,7 +8562,7 @@
         </p:nvSpPr>
         <p:spPr>
           <a:xfrm>
-            <a:off x="7114032" y="2103120"/>
+            <a:off x="7114032" y="2057400"/>
             <a:ext cx="2834640" cy="1280160"/>
           </a:xfrm>
           <a:prstGeom prst="rect">
@@ -8581,7 +8588,7 @@
                 </a:solidFill>
                 <a:latin typeface="Segoe UI"/>
               </a:rPr>
-              <a:t>38x</a:t>
+              <a:t>38x  /  29x</a:t>
             </a:r>
           </a:p>
         </p:txBody>
@@ -8594,7 +8601,7 @@
         </p:nvSpPr>
         <p:spPr>
           <a:xfrm>
-            <a:off x="7114032" y="3246120"/>
+            <a:off x="7114032" y="3200400"/>
             <a:ext cx="2834640" cy="1005840"/>
           </a:xfrm>
           <a:prstGeom prst="rect">
@@ -8620,7 +8627,7 @@
                 </a:solidFill>
                 <a:latin typeface="Segoe UI"/>
               </a:rPr>
-              <a:t>short — and the gap is checked by the Lean kernel, not by us</a:t>
+              <a:t>short on those proxies, and on the widest combination the measured record allows — both checked by the Lean kernel</a:t>
             </a:r>
           </a:p>
         </p:txBody>
@@ -8633,7 +8640,7 @@
         </p:nvSpPr>
         <p:spPr>
           <a:xfrm>
-            <a:off x="713232" y="3931920"/>
+            <a:off x="713232" y="3794760"/>
             <a:ext cx="6766560" cy="274320"/>
           </a:xfrm>
           <a:prstGeom prst="rect">
@@ -8672,7 +8679,7 @@
         </p:nvSpPr>
         <p:spPr>
           <a:xfrm>
-            <a:off x="7637983" y="3931920"/>
+            <a:off x="7637983" y="3794760"/>
             <a:ext cx="3840480" cy="274320"/>
           </a:xfrm>
           <a:prstGeom prst="rect">
@@ -8711,7 +8718,7 @@
         </p:nvSpPr>
         <p:spPr>
           <a:xfrm>
-            <a:off x="713232" y="4242816"/>
+            <a:off x="713232" y="4105656"/>
             <a:ext cx="6766560" cy="274320"/>
           </a:xfrm>
           <a:prstGeom prst="rect">
@@ -8750,7 +8757,7 @@
         </p:nvSpPr>
         <p:spPr>
           <a:xfrm>
-            <a:off x="7637983" y="4242816"/>
+            <a:off x="7637983" y="4105656"/>
             <a:ext cx="3840480" cy="274320"/>
           </a:xfrm>
           <a:prstGeom prst="rect">
@@ -8789,7 +8796,7 @@
         </p:nvSpPr>
         <p:spPr>
           <a:xfrm>
-            <a:off x="713232" y="4553712"/>
+            <a:off x="713232" y="4416552"/>
             <a:ext cx="6766560" cy="274320"/>
           </a:xfrm>
           <a:prstGeom prst="rect">
@@ -8828,7 +8835,7 @@
         </p:nvSpPr>
         <p:spPr>
           <a:xfrm>
-            <a:off x="7637983" y="4553712"/>
+            <a:off x="7637983" y="4416552"/>
             <a:ext cx="3840480" cy="274320"/>
           </a:xfrm>
           <a:prstGeom prst="rect">
@@ -8867,7 +8874,7 @@
         </p:nvSpPr>
         <p:spPr>
           <a:xfrm>
-            <a:off x="713232" y="5074920"/>
+            <a:off x="713232" y="4846320"/>
             <a:ext cx="10765231" cy="91440"/>
           </a:xfrm>
           <a:prstGeom prst="roundRect">
@@ -8878,7 +8885,7 @@
           </a:solidFill>
           <a:ln>
             <a:solidFill>
-              <a:srgbClr val="EB6834"/>
+              <a:srgbClr val="0E7C86"/>
             </a:solidFill>
           </a:ln>
           <a:effectLst/>
@@ -8898,7 +8905,9 @@
           </a:fontRef>
         </p:style>
         <p:txBody>
-          <a:bodyPr rtlCol="0" anchor="ctr" wrap="square"/>
+          <a:bodyPr rtlCol="0" anchor="ctr" wrap="square">
+            <a:spAutoFit/>
+          </a:bodyPr>
           <a:lstStyle/>
           <a:p>
             <a:pPr algn="ctr"/>
@@ -8909,7 +8918,7 @@
                 </a:solidFill>
                 <a:latin typeface="Segoe UI"/>
               </a:rPr>
-              <a:t>WHAT A FISH THAT REALLY FLEW WOULD NEED, AND NO ANIMAL HAS: a flight muscle that does not fit in the animal. At 16% of a 60 g body and ordinary muscle density that is 9.06e-6 m³ of muscle, and only 29.5% of it fits inside the body at the pectoral girdle — a geometric consequence of the specification, not an opinion. Beside it: a cardiac output of 2,365 ml/min/kg, 36x the sourced fish maximum. Building the design as real geometry was itself a test, and it caught something three rounds of equations did not. The flier is hypothetical throughout and now carries a requirement nothing can satisfy; it is not a validated design.</a:t>
+              <a:t>TWO CEILINGS, AND THE SMALLER MULTIPLIER IS THE STRONGER CLAIM. 0.0357 W is the product of the four proxy values this candidate commits to, so 38x rules flight out for THAT ONE PARAMETERISATION. 0.0458 W instead takes the MAXIMUM of each measured teleost range (eta &lt;= 0.15, E &lt;= 19.35 J/ml, Q &lt;= 0.075 ml/s, Ca &lt;= 0.21 ml/ml), so it is necessarily the larger ceiling and the smaller multiplier — and 29x rules it out for EVERY animal the measured record allows. Neither supersedes the other: different quantities, both kernel-checked. Reject it and C14 still rules, but only on the particular proxies a candidate commits, not on every teleost.</a:t>
             </a:r>
           </a:p>
         </p:txBody>
@@ -8948,7 +8957,7 @@
                 </a:solidFill>
                 <a:latin typeface="Segoe UI"/>
               </a:rPr>
-              <a:t>What it rests on: Fick's principle, aerobic power rather than burst power, and teleost proxy values for cardiac output, arterial oxygen and efficiency — no flying-fish physiology exists, so the proxies are what the elimination rests on. What it does NOT bound: gliding (a flying fish is a glider), and short burst flight. 3 of 3 candidates eliminated, each by a theorem the compiler accepted; on the same candidates 41 other constraints could not be fired at all for want of an input. This is a proof about a model instantiated with proxy numbers and it carries that scope — it is not a fact about a fish.</a:t>
+              <a:t>What it rests on: Fick's principle, aerobic power rather than burst power, and teleost proxy values — no flying-fish physiology exists, so the proxies are what the elimination rests on. What it does NOT bound: gliding (a flying fish is a glider), and short burst flight. 3 of 3 candidates eliminated by theorems the compiler accepted; 41 other constraints on the same candidates could not be fired at all, for want of an input. A proof about a model, not a fact about a fish.</a:t>
             </a:r>
           </a:p>
         </p:txBody>
@@ -9106,32 +9115,243 @@
                 </a:solidFill>
                 <a:latin typeface="Segoe UI"/>
               </a:rPr>
-              <a:t>One glide cannot explain the long flights.</a:t>
-            </a:r>
-          </a:p>
-        </p:txBody>
-      </p:sp>
-      <p:graphicFrame>
-        <p:nvGraphicFramePr>
-          <p:cNvPr id="5" name="Chart 4"/>
-          <p:cNvGraphicFramePr>
-            <a:graphicFrameLocks noGrp="1"/>
-          </p:cNvGraphicFramePr>
-          <p:nvPr/>
-        </p:nvGraphicFramePr>
-        <p:xfrm>
-          <a:off x="713232" y="2103120"/>
-          <a:ext cx="10490911" cy="2834640"/>
-        </p:xfrm>
-        <a:graphic>
-          <a:graphicData uri="http://schemas.openxmlformats.org/drawingml/2006/chart">
-            <c:chart xmlns:c="http://schemas.openxmlformats.org/drawingml/2006/chart" r:id="rId2"/>
-          </a:graphicData>
-        </a:graphic>
-      </p:graphicFrame>
+              <a:t>What a fish that really flew would need,</a:t>
+            </a:r>
+          </a:p>
+          <a:p>
+            <a:pPr algn="l">
+              <a:lnSpc>
+                <a:spcPct val="92000"/>
+              </a:lnSpc>
+            </a:pPr>
+            <a:r>
+              <a:rPr sz="4000" b="1">
+                <a:solidFill>
+                  <a:srgbClr val="14201F"/>
+                </a:solidFill>
+                <a:latin typeface="Segoe UI"/>
+              </a:rPr>
+              <a:t>and no animal has.</a:t>
+            </a:r>
+          </a:p>
+        </p:txBody>
+      </p:sp>
+      <p:sp>
+        <p:nvSpPr>
+          <p:cNvPr id="5" name="TextBox 4"/>
+          <p:cNvSpPr txBox="1"/>
+          <p:nvPr/>
+        </p:nvSpPr>
+        <p:spPr>
+          <a:xfrm>
+            <a:off x="713232" y="2194560"/>
+            <a:ext cx="2834640" cy="1280160"/>
+          </a:xfrm>
+          <a:prstGeom prst="rect">
+            <a:avLst/>
+          </a:prstGeom>
+          <a:noFill/>
+        </p:spPr>
+        <p:txBody>
+          <a:bodyPr wrap="square">
+            <a:spAutoFit/>
+          </a:bodyPr>
+          <a:lstStyle/>
+          <a:p>
+            <a:pPr algn="l">
+              <a:lnSpc>
+                <a:spcPct val="100000"/>
+              </a:lnSpc>
+            </a:pPr>
+            <a:r>
+              <a:rPr sz="5400" b="1">
+                <a:solidFill>
+                  <a:srgbClr val="EB6834"/>
+                </a:solidFill>
+                <a:latin typeface="Segoe UI"/>
+              </a:rPr>
+              <a:t>29.5%</a:t>
+            </a:r>
+          </a:p>
+        </p:txBody>
+      </p:sp>
       <p:sp>
         <p:nvSpPr>
           <p:cNvPr id="6" name="TextBox 5"/>
+          <p:cNvSpPr txBox="1"/>
+          <p:nvPr/>
+        </p:nvSpPr>
+        <p:spPr>
+          <a:xfrm>
+            <a:off x="713232" y="3337560"/>
+            <a:ext cx="2834640" cy="1005840"/>
+          </a:xfrm>
+          <a:prstGeom prst="rect">
+            <a:avLst/>
+          </a:prstGeom>
+          <a:noFill/>
+        </p:spPr>
+        <p:txBody>
+          <a:bodyPr wrap="square">
+            <a:spAutoFit/>
+          </a:bodyPr>
+          <a:lstStyle/>
+          <a:p>
+            <a:pPr algn="l">
+              <a:lnSpc>
+                <a:spcPct val="112000"/>
+              </a:lnSpc>
+            </a:pPr>
+            <a:r>
+              <a:rPr sz="1100" b="0">
+                <a:solidFill>
+                  <a:srgbClr val="5A6B69"/>
+                </a:solidFill>
+                <a:latin typeface="Segoe UI"/>
+              </a:rPr>
+              <a:t>of the required flight muscle actually fits inside the body at the pectoral girdle, in the geometry the specification itself implies</a:t>
+            </a:r>
+          </a:p>
+        </p:txBody>
+      </p:sp>
+      <p:sp>
+        <p:nvSpPr>
+          <p:cNvPr id="7" name="TextBox 6"/>
+          <p:cNvSpPr txBox="1"/>
+          <p:nvPr/>
+        </p:nvSpPr>
+        <p:spPr>
+          <a:xfrm>
+            <a:off x="3913632" y="2194560"/>
+            <a:ext cx="2834640" cy="1280160"/>
+          </a:xfrm>
+          <a:prstGeom prst="rect">
+            <a:avLst/>
+          </a:prstGeom>
+          <a:noFill/>
+        </p:spPr>
+        <p:txBody>
+          <a:bodyPr wrap="square">
+            <a:spAutoFit/>
+          </a:bodyPr>
+          <a:lstStyle/>
+          <a:p>
+            <a:pPr algn="l">
+              <a:lnSpc>
+                <a:spcPct val="100000"/>
+              </a:lnSpc>
+            </a:pPr>
+            <a:r>
+              <a:rPr sz="5400" b="1">
+                <a:solidFill>
+                  <a:srgbClr val="EB6834"/>
+                </a:solidFill>
+                <a:latin typeface="Segoe UI"/>
+              </a:rPr>
+              <a:t>2,365</a:t>
+            </a:r>
+          </a:p>
+        </p:txBody>
+      </p:sp>
+      <p:sp>
+        <p:nvSpPr>
+          <p:cNvPr id="8" name="TextBox 7"/>
+          <p:cNvSpPr txBox="1"/>
+          <p:nvPr/>
+        </p:nvSpPr>
+        <p:spPr>
+          <a:xfrm>
+            <a:off x="3913632" y="3337560"/>
+            <a:ext cx="2834640" cy="1005840"/>
+          </a:xfrm>
+          <a:prstGeom prst="rect">
+            <a:avLst/>
+          </a:prstGeom>
+          <a:noFill/>
+        </p:spPr>
+        <p:txBody>
+          <a:bodyPr wrap="square">
+            <a:spAutoFit/>
+          </a:bodyPr>
+          <a:lstStyle/>
+          <a:p>
+            <a:pPr algn="l">
+              <a:lnSpc>
+                <a:spcPct val="112000"/>
+              </a:lnSpc>
+            </a:pPr>
+            <a:r>
+              <a:rPr sz="1100" b="0">
+                <a:solidFill>
+                  <a:srgbClr val="5A6B69"/>
+                </a:solidFill>
+                <a:latin typeface="Segoe UI"/>
+              </a:rPr>
+              <a:t>ml/min/kg of cardiac output — 36x the sourced fish maximum</a:t>
+            </a:r>
+          </a:p>
+        </p:txBody>
+      </p:sp>
+      <p:sp>
+        <p:nvSpPr>
+          <p:cNvPr id="9" name="Rounded Rectangle 8"/>
+          <p:cNvSpPr/>
+          <p:nvPr/>
+        </p:nvSpPr>
+        <p:spPr>
+          <a:xfrm>
+            <a:off x="713232" y="4206240"/>
+            <a:ext cx="10765231" cy="91440"/>
+          </a:xfrm>
+          <a:prstGeom prst="roundRect">
+            <a:avLst/>
+          </a:prstGeom>
+          <a:solidFill>
+            <a:srgbClr val="FFFFFF"/>
+          </a:solidFill>
+          <a:ln>
+            <a:solidFill>
+              <a:srgbClr val="EB6834"/>
+            </a:solidFill>
+          </a:ln>
+          <a:effectLst/>
+        </p:spPr>
+        <p:style>
+          <a:lnRef idx="1">
+            <a:schemeClr val="accent1"/>
+          </a:lnRef>
+          <a:fillRef idx="3">
+            <a:schemeClr val="accent1"/>
+          </a:fillRef>
+          <a:effectRef idx="2">
+            <a:schemeClr val="accent1"/>
+          </a:effectRef>
+          <a:fontRef idx="minor">
+            <a:schemeClr val="lt1"/>
+          </a:fontRef>
+        </p:style>
+        <p:txBody>
+          <a:bodyPr rtlCol="0" anchor="ctr" wrap="square">
+            <a:spAutoFit/>
+          </a:bodyPr>
+          <a:lstStyle/>
+          <a:p>
+            <a:pPr algn="ctr"/>
+            <a:r>
+              <a:rPr sz="1100">
+                <a:solidFill>
+                  <a:srgbClr val="14201F"/>
+                </a:solidFill>
+                <a:latin typeface="Segoe UI"/>
+              </a:rPr>
+              <a:t>A flight muscle that does not fit in the animal. At 16% of a 60 g body and ordinary muscle density that is 9.06e-6 m³ of muscle, and only 29.5% of it fits inside the body at the pectoral girdle. That is a geometric consequence of the specification, not an opinion — and building the design as real geometry was itself a test, which caught something three rounds of equations did not.</a:t>
+            </a:r>
+          </a:p>
+        </p:txBody>
+      </p:sp>
+      <p:sp>
+        <p:nvSpPr>
+          <p:cNvPr id="10" name="TextBox 9"/>
           <p:cNvSpPr txBox="1"/>
           <p:nvPr/>
         </p:nvSpPr>
@@ -9163,7 +9383,7 @@
                 </a:solidFill>
                 <a:latin typeface="Segoe UI"/>
               </a:rPr>
-              <a:t>A steady glide can only trade height for distance, so its range is at most height times lift-to-drag. At the measured ratio that is 35 m from the greatest recorded flight height, or 40.7 m once the measured ground effect is allowed — and the field reports 50 m. So the single-glide reading is eliminated, and taxiing re-launches or wind must account for the rest. The field figures are quoted second-hand and labelled secondary; the 400 m one is already described by its own source as a sequence of taxiing and glides, not one glide. Our simulator reproduces that shape: 6 glides and 288 m in 23.4 s, from a model changed after seeing results, so that run is exploratory and labelled so.</a:t>
+              <a:t>The flier is hypothetical throughout and now carries a requirement nothing can satisfy. It is not a validated design, and nothing in this deck presents it as one.</a:t>
             </a:r>
           </a:p>
         </p:txBody>
@@ -9321,482 +9541,32 @@
                 </a:solidFill>
                 <a:latin typeface="Segoe UI"/>
               </a:rPr>
-              <a:t>Four sequence results. Three of them say no.</a:t>
-            </a:r>
-          </a:p>
-        </p:txBody>
-      </p:sp>
-      <p:sp>
-        <p:nvSpPr>
-          <p:cNvPr id="5" name="TextBox 4"/>
-          <p:cNvSpPr txBox="1"/>
-          <p:nvPr/>
-        </p:nvSpPr>
-        <p:spPr>
-          <a:xfrm>
-            <a:off x="713232" y="2011680"/>
-            <a:ext cx="7564831" cy="310896"/>
-          </a:xfrm>
-          <a:prstGeom prst="rect">
-            <a:avLst/>
-          </a:prstGeom>
-          <a:noFill/>
-        </p:spPr>
-        <p:txBody>
-          <a:bodyPr wrap="square">
-            <a:spAutoFit/>
-          </a:bodyPr>
-          <a:lstStyle/>
-          <a:p>
-            <a:pPr algn="l">
-              <a:lnSpc>
-                <a:spcPct val="100000"/>
-              </a:lnSpc>
-            </a:pPr>
-            <a:r>
-              <a:rPr sz="1400" b="1">
-                <a:solidFill>
-                  <a:srgbClr val="14201F"/>
-                </a:solidFill>
-                <a:latin typeface="Segoe UI"/>
-              </a:rPr>
-              <a:t>Gliders do not converge</a:t>
-            </a:r>
-          </a:p>
-        </p:txBody>
-      </p:sp>
+              <a:t>One glide cannot explain the long flights.</a:t>
+            </a:r>
+          </a:p>
+        </p:txBody>
+      </p:sp>
+      <p:graphicFrame>
+        <p:nvGraphicFramePr>
+          <p:cNvPr id="5" name="Chart 4"/>
+          <p:cNvGraphicFramePr>
+            <a:graphicFrameLocks noGrp="1"/>
+          </p:cNvGraphicFramePr>
+          <p:nvPr/>
+        </p:nvGraphicFramePr>
+        <p:xfrm>
+          <a:off x="713232" y="2103120"/>
+          <a:ext cx="10490911" cy="2834640"/>
+        </p:xfrm>
+        <a:graphic>
+          <a:graphicData uri="http://schemas.openxmlformats.org/drawingml/2006/chart">
+            <c:chart xmlns:c="http://schemas.openxmlformats.org/drawingml/2006/chart" r:id="rId2"/>
+          </a:graphicData>
+        </a:graphic>
+      </p:graphicFrame>
       <p:sp>
         <p:nvSpPr>
           <p:cNvPr id="6" name="TextBox 5"/>
-          <p:cNvSpPr txBox="1"/>
-          <p:nvPr/>
-        </p:nvSpPr>
-        <p:spPr>
-          <a:xfrm>
-            <a:off x="8552383" y="2011680"/>
-            <a:ext cx="2926080" cy="310896"/>
-          </a:xfrm>
-          <a:prstGeom prst="rect">
-            <a:avLst/>
-          </a:prstGeom>
-          <a:noFill/>
-        </p:spPr>
-        <p:txBody>
-          <a:bodyPr wrap="square">
-            <a:spAutoFit/>
-          </a:bodyPr>
-          <a:lstStyle/>
-          <a:p>
-            <a:pPr algn="r">
-              <a:lnSpc>
-                <a:spcPct val="100000"/>
-              </a:lnSpc>
-            </a:pPr>
-            <a:r>
-              <a:rPr sz="1400" b="1">
-                <a:solidFill>
-                  <a:srgbClr val="EB6834"/>
-                </a:solidFill>
-                <a:latin typeface="Segoe UI"/>
-              </a:rPr>
-              <a:t>11 vs 17</a:t>
-            </a:r>
-          </a:p>
-        </p:txBody>
-      </p:sp>
-      <p:sp>
-        <p:nvSpPr>
-          <p:cNvPr id="7" name="TextBox 6"/>
-          <p:cNvSpPr txBox="1"/>
-          <p:nvPr/>
-        </p:nvSpPr>
-        <p:spPr>
-          <a:xfrm>
-            <a:off x="713232" y="2286000"/>
-            <a:ext cx="10399471" cy="713232"/>
-          </a:xfrm>
-          <a:prstGeom prst="rect">
-            <a:avLst/>
-          </a:prstGeom>
-          <a:noFill/>
-        </p:spPr>
-        <p:txBody>
-          <a:bodyPr wrap="square">
-            <a:spAutoFit/>
-          </a:bodyPr>
-          <a:lstStyle/>
-          <a:p>
-            <a:pPr algn="l">
-              <a:lnSpc>
-                <a:spcPct val="112000"/>
-              </a:lnSpc>
-            </a:pPr>
-            <a:r>
-              <a:rPr sz="1000" b="0">
-                <a:solidFill>
-                  <a:srgbClr val="5A6B69"/>
-                </a:solidFill>
-                <a:latin typeface="Segoe UI"/>
-              </a:rPr>
-              <a:t>Across 9 fin genes, 11 alignment columns show a residue shared by independent gliders and absent from each lineage's non-gliding relative — against 17 for the same count with the roles swapped. Similarity follows ancestry, not gliding. The genes were picked from fin biology, so this says nothing about the rest of the genome.</a:t>
-            </a:r>
-          </a:p>
-        </p:txBody>
-      </p:sp>
-      <p:sp>
-        <p:nvSpPr>
-          <p:cNvPr id="8" name="TextBox 7"/>
-          <p:cNvSpPr txBox="1"/>
-          <p:nvPr/>
-        </p:nvSpPr>
-        <p:spPr>
-          <a:xfrm>
-            <a:off x="713232" y="2962656"/>
-            <a:ext cx="7564831" cy="310896"/>
-          </a:xfrm>
-          <a:prstGeom prst="rect">
-            <a:avLst/>
-          </a:prstGeom>
-          <a:noFill/>
-        </p:spPr>
-        <p:txBody>
-          <a:bodyPr wrap="square">
-            <a:spAutoFit/>
-          </a:bodyPr>
-          <a:lstStyle/>
-          <a:p>
-            <a:pPr algn="l">
-              <a:lnSpc>
-                <a:spcPct val="100000"/>
-              </a:lnSpc>
-            </a:pPr>
-            <a:r>
-              <a:rPr sz="1400" b="1">
-                <a:solidFill>
-                  <a:srgbClr val="14201F"/>
-                </a:solidFill>
-                <a:latin typeface="Segoe UI"/>
-              </a:rPr>
-              <a:t>The lat4a substitution tracks gliding inside the fishes only</a:t>
-            </a:r>
-          </a:p>
-        </p:txBody>
-      </p:sp>
-      <p:sp>
-        <p:nvSpPr>
-          <p:cNvPr id="9" name="TextBox 8"/>
-          <p:cNvSpPr txBox="1"/>
-          <p:nvPr/>
-        </p:nvSpPr>
-        <p:spPr>
-          <a:xfrm>
-            <a:off x="8552383" y="2962656"/>
-            <a:ext cx="2926080" cy="310896"/>
-          </a:xfrm>
-          <a:prstGeom prst="rect">
-            <a:avLst/>
-          </a:prstGeom>
-          <a:noFill/>
-        </p:spPr>
-        <p:txBody>
-          <a:bodyPr wrap="square">
-            <a:spAutoFit/>
-          </a:bodyPr>
-          <a:lstStyle/>
-          <a:p>
-            <a:pPr algn="r">
-              <a:lnSpc>
-                <a:spcPct val="100000"/>
-              </a:lnSpc>
-            </a:pPr>
-            <a:r>
-              <a:rPr sz="1400" b="1">
-                <a:solidFill>
-                  <a:srgbClr val="1BAF7A"/>
-                </a:solidFill>
-                <a:latin typeface="Segoe UI"/>
-              </a:rPr>
-              <a:t>8/9  ·  23/24</a:t>
-            </a:r>
-          </a:p>
-        </p:txBody>
-      </p:sp>
-      <p:sp>
-        <p:nvSpPr>
-          <p:cNvPr id="10" name="TextBox 9"/>
-          <p:cNvSpPr txBox="1"/>
-          <p:nvPr/>
-        </p:nvSpPr>
-        <p:spPr>
-          <a:xfrm>
-            <a:off x="713232" y="3236976"/>
-            <a:ext cx="10399471" cy="713232"/>
-          </a:xfrm>
-          <a:prstGeom prst="rect">
-            <a:avLst/>
-          </a:prstGeom>
-          <a:noFill/>
-        </p:spPr>
-        <p:txBody>
-          <a:bodyPr wrap="square">
-            <a:spAutoFit/>
-          </a:bodyPr>
-          <a:lstStyle/>
-          <a:p>
-            <a:pPr algn="l">
-              <a:lnSpc>
-                <a:spcPct val="112000"/>
-              </a:lnSpc>
-            </a:pPr>
-            <a:r>
-              <a:rPr sz="1000" b="0">
-                <a:solidFill>
-                  <a:srgbClr val="5A6B69"/>
-                </a:solidFill>
-                <a:latin typeface="Segoe UI"/>
-              </a:rPr>
-              <a:t>L in 8 of 9 flying fishes and in both gliding halfbeaks, against 23 of 24 non-gliding relatives carrying F. But all three bats, both colugos, the sugar glider, mouse, human and every outgroup scored carry F too, so this is not convergence with gliding mammals. Tracking is not causing.</a:t>
-            </a:r>
-          </a:p>
-        </p:txBody>
-      </p:sp>
-      <p:sp>
-        <p:nvSpPr>
-          <p:cNvPr id="11" name="TextBox 10"/>
-          <p:cNvSpPr txBox="1"/>
-          <p:nvPr/>
-        </p:nvSpPr>
-        <p:spPr>
-          <a:xfrm>
-            <a:off x="713232" y="3913632"/>
-            <a:ext cx="7564831" cy="310896"/>
-          </a:xfrm>
-          <a:prstGeom prst="rect">
-            <a:avLst/>
-          </a:prstGeom>
-          <a:noFill/>
-        </p:spPr>
-        <p:txBody>
-          <a:bodyPr wrap="square">
-            <a:spAutoFit/>
-          </a:bodyPr>
-          <a:lstStyle/>
-          <a:p>
-            <a:pPr algn="l">
-              <a:lnSpc>
-                <a:spcPct val="100000"/>
-              </a:lnSpc>
-            </a:pPr>
-            <a:r>
-              <a:rPr sz="1400" b="1">
-                <a:solidFill>
-                  <a:srgbClr val="14201F"/>
-                </a:solidFill>
-                <a:latin typeface="Segoe UI"/>
-              </a:rPr>
-              <a:t>The derived-site panel is not a dose-response</a:t>
-            </a:r>
-          </a:p>
-        </p:txBody>
-      </p:sp>
-      <p:sp>
-        <p:nvSpPr>
-          <p:cNvPr id="12" name="TextBox 11"/>
-          <p:cNvSpPr txBox="1"/>
-          <p:nvPr/>
-        </p:nvSpPr>
-        <p:spPr>
-          <a:xfrm>
-            <a:off x="8552383" y="3913632"/>
-            <a:ext cx="2926080" cy="310896"/>
-          </a:xfrm>
-          <a:prstGeom prst="rect">
-            <a:avLst/>
-          </a:prstGeom>
-          <a:noFill/>
-        </p:spPr>
-        <p:txBody>
-          <a:bodyPr wrap="square">
-            <a:spAutoFit/>
-          </a:bodyPr>
-          <a:lstStyle/>
-          <a:p>
-            <a:pPr algn="r">
-              <a:lnSpc>
-                <a:spcPct val="100000"/>
-              </a:lnSpc>
-            </a:pPr>
-            <a:r>
-              <a:rPr sz="1400" b="1">
-                <a:solidFill>
-                  <a:srgbClr val="EB6834"/>
-                </a:solidFill>
-                <a:latin typeface="Segoe UI"/>
-              </a:rPr>
-              <a:t>24 at 0.274  ·  21.4 at 0.687</a:t>
-            </a:r>
-          </a:p>
-        </p:txBody>
-      </p:sp>
-      <p:sp>
-        <p:nvSpPr>
-          <p:cNvPr id="13" name="TextBox 12"/>
-          <p:cNvSpPr txBox="1"/>
-          <p:nvPr/>
-        </p:nvSpPr>
-        <p:spPr>
-          <a:xfrm>
-            <a:off x="713232" y="4187952"/>
-            <a:ext cx="10399471" cy="713232"/>
-          </a:xfrm>
-          <a:prstGeom prst="rect">
-            <a:avLst/>
-          </a:prstGeom>
-          <a:noFill/>
-        </p:spPr>
-        <p:txBody>
-          <a:bodyPr wrap="square">
-            <a:spAutoFit/>
-          </a:bodyPr>
-          <a:lstStyle/>
-          <a:p>
-            <a:pPr algn="l">
-              <a:lnSpc>
-                <a:spcPct val="112000"/>
-              </a:lnSpc>
-            </a:pPr>
-            <a:r>
-              <a:rPr sz="1000" b="0">
-                <a:solidFill>
-                  <a:srgbClr val="5A6B69"/>
-                </a:solidFill>
-                <a:latin typeface="Segoe UI"/>
-              </a:rPr>
-              <a:t>Gliding halfbeaks carry a mean 24 of 38 derived states at a fin-to-body ratio of 0.274; flying fishes carry 21.4 at 0.687. The group with the far smaller fin carries slightly more derived residues. The non-gliders' zero is circular by construction and is not shown as a finding; four groups is a ladder to read, not a statistical test.</a:t>
-            </a:r>
-          </a:p>
-        </p:txBody>
-      </p:sp>
-      <p:sp>
-        <p:nvSpPr>
-          <p:cNvPr id="14" name="TextBox 13"/>
-          <p:cNvSpPr txBox="1"/>
-          <p:nvPr/>
-        </p:nvSpPr>
-        <p:spPr>
-          <a:xfrm>
-            <a:off x="713232" y="4864608"/>
-            <a:ext cx="7564831" cy="310896"/>
-          </a:xfrm>
-          <a:prstGeom prst="rect">
-            <a:avLst/>
-          </a:prstGeom>
-          <a:noFill/>
-        </p:spPr>
-        <p:txBody>
-          <a:bodyPr wrap="square">
-            <a:spAutoFit/>
-          </a:bodyPr>
-          <a:lstStyle/>
-          <a:p>
-            <a:pPr algn="l">
-              <a:lnSpc>
-                <a:spcPct val="100000"/>
-              </a:lnSpc>
-            </a:pPr>
-            <a:r>
-              <a:rPr sz="1400" b="1">
-                <a:solidFill>
-                  <a:srgbClr val="14201F"/>
-                </a:solidFill>
-                <a:latin typeface="Segoe UI"/>
-              </a:rPr>
-              <a:t>An "engineered" genome is a handful of edits</a:t>
-            </a:r>
-          </a:p>
-        </p:txBody>
-      </p:sp>
-      <p:sp>
-        <p:nvSpPr>
-          <p:cNvPr id="15" name="TextBox 14"/>
-          <p:cNvSpPr txBox="1"/>
-          <p:nvPr/>
-        </p:nvSpPr>
-        <p:spPr>
-          <a:xfrm>
-            <a:off x="8552383" y="4864608"/>
-            <a:ext cx="2926080" cy="310896"/>
-          </a:xfrm>
-          <a:prstGeom prst="rect">
-            <a:avLst/>
-          </a:prstGeom>
-          <a:noFill/>
-        </p:spPr>
-        <p:txBody>
-          <a:bodyPr wrap="square">
-            <a:spAutoFit/>
-          </a:bodyPr>
-          <a:lstStyle/>
-          <a:p>
-            <a:pPr algn="r">
-              <a:lnSpc>
-                <a:spcPct val="100000"/>
-              </a:lnSpc>
-            </a:pPr>
-            <a:r>
-              <a:rPr sz="1400" b="1">
-                <a:solidFill>
-                  <a:srgbClr val="EB6834"/>
-                </a:solidFill>
-                <a:latin typeface="Segoe UI"/>
-              </a:rPr>
-              <a:t>1 vs 7,300</a:t>
-            </a:r>
-          </a:p>
-        </p:txBody>
-      </p:sp>
-      <p:sp>
-        <p:nvSpPr>
-          <p:cNvPr id="16" name="TextBox 15"/>
-          <p:cNvSpPr txBox="1"/>
-          <p:nvPr/>
-        </p:nvSpPr>
-        <p:spPr>
-          <a:xfrm>
-            <a:off x="713232" y="5138928"/>
-            <a:ext cx="10399471" cy="713232"/>
-          </a:xfrm>
-          <a:prstGeom prst="rect">
-            <a:avLst/>
-          </a:prstGeom>
-          <a:noFill/>
-        </p:spPr>
-        <p:txBody>
-          <a:bodyPr wrap="square">
-            <a:spAutoFit/>
-          </a:bodyPr>
-          <a:lstStyle/>
-          <a:p>
-            <a:pPr algn="l">
-              <a:lnSpc>
-                <a:spcPct val="112000"/>
-              </a:lnSpc>
-            </a:pPr>
-            <a:r>
-              <a:rPr sz="1000" b="0">
-                <a:solidFill>
-                  <a:srgbClr val="5A6B69"/>
-                </a:solidFill>
-                <a:latin typeface="Segoe UI"/>
-              </a:rPr>
-              <a:t>2 edited loci change 1 amino acid; the other edit is regulatory and changes none. In just 37 of our causal-chain proteins, zebrafish and medaka differ by 7,300 amino-acid substitutions (16,054 positions counting indels). Coding only, in a tiny gene sample.</a:t>
-            </a:r>
-          </a:p>
-        </p:txBody>
-      </p:sp>
-      <p:sp>
-        <p:nvSpPr>
-          <p:cNvPr id="17" name="TextBox 16"/>
           <p:cNvSpPr txBox="1"/>
           <p:nvPr/>
         </p:nvSpPr>
@@ -9828,7 +9598,7 @@
                 </a:solidFill>
                 <a:latin typeface="Segoe UI"/>
               </a:rPr>
-              <a:t>All four are about fin enlargement for gliding, the trait Daane et al. 2021 measured (10.1016/j.cub.2021.08.054); the fin ratios, the convergent-substitution panel and the captured exons are theirs. Three of these close a door we would have liked open, and the one that holds, holds only inside the Beloniformes. No bird sequence, assembly or annotation was fetched: Aves is this project's frozen holdout.</a:t>
+              <a:t>A steady glide can only trade height for distance, so its range is at most height times lift-to-drag. At the measured ratio that is 35 m from the greatest recorded flight height, or 40.7 m once the measured ground effect is allowed — and the field reports 50 m. So the single-glide reading is eliminated, and taxiing re-launches or wind must account for the rest. The field figures are quoted second-hand and labelled secondary; the 400 m one is already described by its own source as a sequence of taxiing and glides, not one glide. Our simulator reproduces that shape: 6 glides and 288 m in 23.4 s, from a model changed after seeing results, so that run is exploratory and labelled so.</a:t>
             </a:r>
           </a:p>
         </p:txBody>
@@ -9917,7 +9687,7 @@
           </a:solidFill>
           <a:ln w="12700">
             <a:solidFill>
-              <a:srgbClr val="EB6834"/>
+              <a:srgbClr val="1BAF7A"/>
             </a:solidFill>
           </a:ln>
           <a:effectLst/>
@@ -9944,10 +9714,10 @@
             <a:r>
               <a:rPr sz="900" b="1">
                 <a:solidFill>
-                  <a:srgbClr val="EB6834"/>
-                </a:solidFill>
-              </a:rPr>
-              <a:t>PARTLY EVIDENCED</a:t>
+                  <a:srgbClr val="1BAF7A"/>
+                </a:solidFill>
+              </a:rPr>
+              <a:t>EVIDENCE IN HAND</a:t>
             </a:r>
           </a:p>
         </p:txBody>
@@ -9986,80 +9756,85 @@
                 </a:solidFill>
                 <a:latin typeface="Segoe UI"/>
               </a:rPr>
-              <a:t>357 named pieces. 23 measured numbers behind them.</a:t>
-            </a:r>
-          </a:p>
-        </p:txBody>
-      </p:sp>
-      <p:graphicFrame>
-        <p:nvGraphicFramePr>
-          <p:cNvPr id="5" name="Chart 4"/>
-          <p:cNvGraphicFramePr>
-            <a:graphicFrameLocks noGrp="1"/>
-          </p:cNvGraphicFramePr>
-          <p:nvPr/>
-        </p:nvGraphicFramePr>
-        <p:xfrm>
-          <a:off x="713232" y="2011680"/>
-          <a:ext cx="10490911" cy="2103120"/>
-        </p:xfrm>
-        <a:graphic>
-          <a:graphicData uri="http://schemas.openxmlformats.org/drawingml/2006/chart">
-            <c:chart xmlns:c="http://schemas.openxmlformats.org/drawingml/2006/chart" r:id="rId2"/>
-          </a:graphicData>
-        </a:graphic>
-      </p:graphicFrame>
-      <p:sp>
-        <p:nvSpPr>
-          <p:cNvPr id="6" name="Rounded Rectangle 5"/>
-          <p:cNvSpPr/>
-          <p:nvPr/>
-        </p:nvSpPr>
-        <p:spPr>
-          <a:xfrm>
-            <a:off x="713232" y="4297680"/>
-            <a:ext cx="10765231" cy="91440"/>
-          </a:xfrm>
-          <a:prstGeom prst="roundRect">
-            <a:avLst/>
-          </a:prstGeom>
-          <a:solidFill>
-            <a:srgbClr val="FFFFFF"/>
-          </a:solidFill>
-          <a:ln>
-            <a:solidFill>
-              <a:srgbClr val="0E7C86"/>
-            </a:solidFill>
-          </a:ln>
-          <a:effectLst/>
-        </p:spPr>
-        <p:style>
-          <a:lnRef idx="1">
-            <a:schemeClr val="accent1"/>
-          </a:lnRef>
-          <a:fillRef idx="3">
-            <a:schemeClr val="accent1"/>
-          </a:fillRef>
-          <a:effectRef idx="2">
-            <a:schemeClr val="accent1"/>
-          </a:effectRef>
-          <a:fontRef idx="minor">
-            <a:schemeClr val="lt1"/>
-          </a:fontRef>
-        </p:style>
-        <p:txBody>
-          <a:bodyPr rtlCol="0" anchor="ctr" wrap="square"/>
-          <a:lstStyle/>
-          <a:p>
-            <a:pPr algn="ctr"/>
-            <a:r>
-              <a:rPr sz="1100">
+              <a:t>Four sequence results. Three of them say no.</a:t>
+            </a:r>
+          </a:p>
+        </p:txBody>
+      </p:sp>
+      <p:sp>
+        <p:nvSpPr>
+          <p:cNvPr id="5" name="TextBox 4"/>
+          <p:cNvSpPr txBox="1"/>
+          <p:nvPr/>
+        </p:nvSpPr>
+        <p:spPr>
+          <a:xfrm>
+            <a:off x="713232" y="2011680"/>
+            <a:ext cx="7564831" cy="310896"/>
+          </a:xfrm>
+          <a:prstGeom prst="rect">
+            <a:avLst/>
+          </a:prstGeom>
+          <a:noFill/>
+        </p:spPr>
+        <p:txBody>
+          <a:bodyPr wrap="square">
+            <a:spAutoFit/>
+          </a:bodyPr>
+          <a:lstStyle/>
+          <a:p>
+            <a:pPr algn="l">
+              <a:lnSpc>
+                <a:spcPct val="100000"/>
+              </a:lnSpc>
+            </a:pPr>
+            <a:r>
+              <a:rPr sz="1400" b="1">
                 <a:solidFill>
                   <a:srgbClr val="14201F"/>
                 </a:solidFill>
                 <a:latin typeface="Segoe UI"/>
               </a:rPr>
-              <a:t>Evidence-backed: the flying fish rests on exactly ONE measured proportion — pectoral fin length at 0.687 of standard length, the median of 49 museum specimens, read from the measurement file rather than typed in (preserved museum specimens; length only (no fin area, shape or spread)). The two zebrafish models carry 22 sourced proportions and counts between them.   Schematic, and labelled so per piece: everything else, including every count.   Where the ontology ran out: 60 of the flying fish's pieces have no ontology term at all; the manifest records a null and the nearest ancestor it could find, instead of inventing one.</a:t>
+              <a:t>Gliders do not converge</a:t>
+            </a:r>
+          </a:p>
+        </p:txBody>
+      </p:sp>
+      <p:sp>
+        <p:nvSpPr>
+          <p:cNvPr id="6" name="TextBox 5"/>
+          <p:cNvSpPr txBox="1"/>
+          <p:nvPr/>
+        </p:nvSpPr>
+        <p:spPr>
+          <a:xfrm>
+            <a:off x="8552383" y="2011680"/>
+            <a:ext cx="2926080" cy="310896"/>
+          </a:xfrm>
+          <a:prstGeom prst="rect">
+            <a:avLst/>
+          </a:prstGeom>
+          <a:noFill/>
+        </p:spPr>
+        <p:txBody>
+          <a:bodyPr wrap="square">
+            <a:spAutoFit/>
+          </a:bodyPr>
+          <a:lstStyle/>
+          <a:p>
+            <a:pPr algn="r">
+              <a:lnSpc>
+                <a:spcPct val="100000"/>
+              </a:lnSpc>
+            </a:pPr>
+            <a:r>
+              <a:rPr sz="1400" b="1">
+                <a:solidFill>
+                  <a:srgbClr val="EB6834"/>
+                </a:solidFill>
+                <a:latin typeface="Segoe UI"/>
+              </a:rPr>
+              <a:t>11 vs 17</a:t>
             </a:r>
           </a:p>
         </p:txBody>
@@ -10067,6 +9842,396 @@
       <p:sp>
         <p:nvSpPr>
           <p:cNvPr id="7" name="TextBox 6"/>
+          <p:cNvSpPr txBox="1"/>
+          <p:nvPr/>
+        </p:nvSpPr>
+        <p:spPr>
+          <a:xfrm>
+            <a:off x="713232" y="2286000"/>
+            <a:ext cx="10399471" cy="713232"/>
+          </a:xfrm>
+          <a:prstGeom prst="rect">
+            <a:avLst/>
+          </a:prstGeom>
+          <a:noFill/>
+        </p:spPr>
+        <p:txBody>
+          <a:bodyPr wrap="square">
+            <a:spAutoFit/>
+          </a:bodyPr>
+          <a:lstStyle/>
+          <a:p>
+            <a:pPr algn="l">
+              <a:lnSpc>
+                <a:spcPct val="112000"/>
+              </a:lnSpc>
+            </a:pPr>
+            <a:r>
+              <a:rPr sz="1000" b="0">
+                <a:solidFill>
+                  <a:srgbClr val="5A6B69"/>
+                </a:solidFill>
+                <a:latin typeface="Segoe UI"/>
+              </a:rPr>
+              <a:t>Across 9 fin genes, 11 alignment columns show a residue shared by independent gliders and absent from each lineage's non-gliding relative — against 17 for the same count with the roles swapped. Similarity follows ancestry, not gliding. The genes were picked from fin biology, so this says nothing about the rest of the genome.</a:t>
+            </a:r>
+          </a:p>
+        </p:txBody>
+      </p:sp>
+      <p:sp>
+        <p:nvSpPr>
+          <p:cNvPr id="8" name="TextBox 7"/>
+          <p:cNvSpPr txBox="1"/>
+          <p:nvPr/>
+        </p:nvSpPr>
+        <p:spPr>
+          <a:xfrm>
+            <a:off x="713232" y="2962656"/>
+            <a:ext cx="7564831" cy="310896"/>
+          </a:xfrm>
+          <a:prstGeom prst="rect">
+            <a:avLst/>
+          </a:prstGeom>
+          <a:noFill/>
+        </p:spPr>
+        <p:txBody>
+          <a:bodyPr wrap="square">
+            <a:spAutoFit/>
+          </a:bodyPr>
+          <a:lstStyle/>
+          <a:p>
+            <a:pPr algn="l">
+              <a:lnSpc>
+                <a:spcPct val="100000"/>
+              </a:lnSpc>
+            </a:pPr>
+            <a:r>
+              <a:rPr sz="1400" b="1">
+                <a:solidFill>
+                  <a:srgbClr val="14201F"/>
+                </a:solidFill>
+                <a:latin typeface="Segoe UI"/>
+              </a:rPr>
+              <a:t>The lat4a substitution tracks gliding inside the fishes only</a:t>
+            </a:r>
+          </a:p>
+        </p:txBody>
+      </p:sp>
+      <p:sp>
+        <p:nvSpPr>
+          <p:cNvPr id="9" name="TextBox 8"/>
+          <p:cNvSpPr txBox="1"/>
+          <p:nvPr/>
+        </p:nvSpPr>
+        <p:spPr>
+          <a:xfrm>
+            <a:off x="8552383" y="2962656"/>
+            <a:ext cx="2926080" cy="310896"/>
+          </a:xfrm>
+          <a:prstGeom prst="rect">
+            <a:avLst/>
+          </a:prstGeom>
+          <a:noFill/>
+        </p:spPr>
+        <p:txBody>
+          <a:bodyPr wrap="square">
+            <a:spAutoFit/>
+          </a:bodyPr>
+          <a:lstStyle/>
+          <a:p>
+            <a:pPr algn="r">
+              <a:lnSpc>
+                <a:spcPct val="100000"/>
+              </a:lnSpc>
+            </a:pPr>
+            <a:r>
+              <a:rPr sz="1400" b="1">
+                <a:solidFill>
+                  <a:srgbClr val="1BAF7A"/>
+                </a:solidFill>
+                <a:latin typeface="Segoe UI"/>
+              </a:rPr>
+              <a:t>8/9  ·  23/24</a:t>
+            </a:r>
+          </a:p>
+        </p:txBody>
+      </p:sp>
+      <p:sp>
+        <p:nvSpPr>
+          <p:cNvPr id="10" name="TextBox 9"/>
+          <p:cNvSpPr txBox="1"/>
+          <p:nvPr/>
+        </p:nvSpPr>
+        <p:spPr>
+          <a:xfrm>
+            <a:off x="713232" y="3236976"/>
+            <a:ext cx="10399471" cy="713232"/>
+          </a:xfrm>
+          <a:prstGeom prst="rect">
+            <a:avLst/>
+          </a:prstGeom>
+          <a:noFill/>
+        </p:spPr>
+        <p:txBody>
+          <a:bodyPr wrap="square">
+            <a:spAutoFit/>
+          </a:bodyPr>
+          <a:lstStyle/>
+          <a:p>
+            <a:pPr algn="l">
+              <a:lnSpc>
+                <a:spcPct val="112000"/>
+              </a:lnSpc>
+            </a:pPr>
+            <a:r>
+              <a:rPr sz="1000" b="0">
+                <a:solidFill>
+                  <a:srgbClr val="5A6B69"/>
+                </a:solidFill>
+                <a:latin typeface="Segoe UI"/>
+              </a:rPr>
+              <a:t>L in 8 of 9 flying fishes and in both gliding halfbeaks, against 23 of 24 non-gliding relatives carrying F. But all three bats, both colugos, the sugar glider, mouse, human and every outgroup scored carry F too, so this is not convergence with gliding mammals. Tracking is not causing.</a:t>
+            </a:r>
+          </a:p>
+        </p:txBody>
+      </p:sp>
+      <p:sp>
+        <p:nvSpPr>
+          <p:cNvPr id="11" name="TextBox 10"/>
+          <p:cNvSpPr txBox="1"/>
+          <p:nvPr/>
+        </p:nvSpPr>
+        <p:spPr>
+          <a:xfrm>
+            <a:off x="713232" y="3913632"/>
+            <a:ext cx="7564831" cy="310896"/>
+          </a:xfrm>
+          <a:prstGeom prst="rect">
+            <a:avLst/>
+          </a:prstGeom>
+          <a:noFill/>
+        </p:spPr>
+        <p:txBody>
+          <a:bodyPr wrap="square">
+            <a:spAutoFit/>
+          </a:bodyPr>
+          <a:lstStyle/>
+          <a:p>
+            <a:pPr algn="l">
+              <a:lnSpc>
+                <a:spcPct val="100000"/>
+              </a:lnSpc>
+            </a:pPr>
+            <a:r>
+              <a:rPr sz="1400" b="1">
+                <a:solidFill>
+                  <a:srgbClr val="14201F"/>
+                </a:solidFill>
+                <a:latin typeface="Segoe UI"/>
+              </a:rPr>
+              <a:t>The derived-site panel is not a dose-response</a:t>
+            </a:r>
+          </a:p>
+        </p:txBody>
+      </p:sp>
+      <p:sp>
+        <p:nvSpPr>
+          <p:cNvPr id="12" name="TextBox 11"/>
+          <p:cNvSpPr txBox="1"/>
+          <p:nvPr/>
+        </p:nvSpPr>
+        <p:spPr>
+          <a:xfrm>
+            <a:off x="8552383" y="3913632"/>
+            <a:ext cx="2926080" cy="310896"/>
+          </a:xfrm>
+          <a:prstGeom prst="rect">
+            <a:avLst/>
+          </a:prstGeom>
+          <a:noFill/>
+        </p:spPr>
+        <p:txBody>
+          <a:bodyPr wrap="square">
+            <a:spAutoFit/>
+          </a:bodyPr>
+          <a:lstStyle/>
+          <a:p>
+            <a:pPr algn="r">
+              <a:lnSpc>
+                <a:spcPct val="100000"/>
+              </a:lnSpc>
+            </a:pPr>
+            <a:r>
+              <a:rPr sz="1400" b="1">
+                <a:solidFill>
+                  <a:srgbClr val="EB6834"/>
+                </a:solidFill>
+                <a:latin typeface="Segoe UI"/>
+              </a:rPr>
+              <a:t>24 at 0.274  ·  21.4 at 0.687</a:t>
+            </a:r>
+          </a:p>
+        </p:txBody>
+      </p:sp>
+      <p:sp>
+        <p:nvSpPr>
+          <p:cNvPr id="13" name="TextBox 12"/>
+          <p:cNvSpPr txBox="1"/>
+          <p:nvPr/>
+        </p:nvSpPr>
+        <p:spPr>
+          <a:xfrm>
+            <a:off x="713232" y="4187952"/>
+            <a:ext cx="10399471" cy="713232"/>
+          </a:xfrm>
+          <a:prstGeom prst="rect">
+            <a:avLst/>
+          </a:prstGeom>
+          <a:noFill/>
+        </p:spPr>
+        <p:txBody>
+          <a:bodyPr wrap="square">
+            <a:spAutoFit/>
+          </a:bodyPr>
+          <a:lstStyle/>
+          <a:p>
+            <a:pPr algn="l">
+              <a:lnSpc>
+                <a:spcPct val="112000"/>
+              </a:lnSpc>
+            </a:pPr>
+            <a:r>
+              <a:rPr sz="1000" b="0">
+                <a:solidFill>
+                  <a:srgbClr val="5A6B69"/>
+                </a:solidFill>
+                <a:latin typeface="Segoe UI"/>
+              </a:rPr>
+              <a:t>Gliding halfbeaks carry a mean 24 of 38 derived states at a fin-to-body ratio of 0.274; flying fishes carry 21.4 at 0.687. The group with the far smaller fin carries slightly more derived residues. The non-gliders' zero is circular by construction and is not shown as a finding; four groups is a ladder to read, not a statistical test.</a:t>
+            </a:r>
+          </a:p>
+        </p:txBody>
+      </p:sp>
+      <p:sp>
+        <p:nvSpPr>
+          <p:cNvPr id="14" name="TextBox 13"/>
+          <p:cNvSpPr txBox="1"/>
+          <p:nvPr/>
+        </p:nvSpPr>
+        <p:spPr>
+          <a:xfrm>
+            <a:off x="713232" y="4864608"/>
+            <a:ext cx="7564831" cy="310896"/>
+          </a:xfrm>
+          <a:prstGeom prst="rect">
+            <a:avLst/>
+          </a:prstGeom>
+          <a:noFill/>
+        </p:spPr>
+        <p:txBody>
+          <a:bodyPr wrap="square">
+            <a:spAutoFit/>
+          </a:bodyPr>
+          <a:lstStyle/>
+          <a:p>
+            <a:pPr algn="l">
+              <a:lnSpc>
+                <a:spcPct val="100000"/>
+              </a:lnSpc>
+            </a:pPr>
+            <a:r>
+              <a:rPr sz="1400" b="1">
+                <a:solidFill>
+                  <a:srgbClr val="14201F"/>
+                </a:solidFill>
+                <a:latin typeface="Segoe UI"/>
+              </a:rPr>
+              <a:t>An "engineered" genome is a handful of edits</a:t>
+            </a:r>
+          </a:p>
+        </p:txBody>
+      </p:sp>
+      <p:sp>
+        <p:nvSpPr>
+          <p:cNvPr id="15" name="TextBox 14"/>
+          <p:cNvSpPr txBox="1"/>
+          <p:nvPr/>
+        </p:nvSpPr>
+        <p:spPr>
+          <a:xfrm>
+            <a:off x="8552383" y="4864608"/>
+            <a:ext cx="2926080" cy="310896"/>
+          </a:xfrm>
+          <a:prstGeom prst="rect">
+            <a:avLst/>
+          </a:prstGeom>
+          <a:noFill/>
+        </p:spPr>
+        <p:txBody>
+          <a:bodyPr wrap="square">
+            <a:spAutoFit/>
+          </a:bodyPr>
+          <a:lstStyle/>
+          <a:p>
+            <a:pPr algn="r">
+              <a:lnSpc>
+                <a:spcPct val="100000"/>
+              </a:lnSpc>
+            </a:pPr>
+            <a:r>
+              <a:rPr sz="1400" b="1">
+                <a:solidFill>
+                  <a:srgbClr val="EB6834"/>
+                </a:solidFill>
+                <a:latin typeface="Segoe UI"/>
+              </a:rPr>
+              <a:t>1 vs 7,300</a:t>
+            </a:r>
+          </a:p>
+        </p:txBody>
+      </p:sp>
+      <p:sp>
+        <p:nvSpPr>
+          <p:cNvPr id="16" name="TextBox 15"/>
+          <p:cNvSpPr txBox="1"/>
+          <p:nvPr/>
+        </p:nvSpPr>
+        <p:spPr>
+          <a:xfrm>
+            <a:off x="713232" y="5138928"/>
+            <a:ext cx="10399471" cy="713232"/>
+          </a:xfrm>
+          <a:prstGeom prst="rect">
+            <a:avLst/>
+          </a:prstGeom>
+          <a:noFill/>
+        </p:spPr>
+        <p:txBody>
+          <a:bodyPr wrap="square">
+            <a:spAutoFit/>
+          </a:bodyPr>
+          <a:lstStyle/>
+          <a:p>
+            <a:pPr algn="l">
+              <a:lnSpc>
+                <a:spcPct val="112000"/>
+              </a:lnSpc>
+            </a:pPr>
+            <a:r>
+              <a:rPr sz="1000" b="0">
+                <a:solidFill>
+                  <a:srgbClr val="5A6B69"/>
+                </a:solidFill>
+                <a:latin typeface="Segoe UI"/>
+              </a:rPr>
+              <a:t>2 edited loci change 1 amino acid; the other edit is regulatory and changes none. In just 37 of our causal-chain proteins, zebrafish and medaka differ by 7,300 amino-acid substitutions (16,054 positions counting indels). Coding only, in a tiny gene sample.</a:t>
+            </a:r>
+          </a:p>
+        </p:txBody>
+      </p:sp>
+      <p:sp>
+        <p:nvSpPr>
+          <p:cNvPr id="17" name="TextBox 16"/>
           <p:cNvSpPr txBox="1"/>
           <p:nvPr/>
         </p:nvSpPr>
@@ -10098,7 +10263,7 @@
                 </a:solidFill>
                 <a:latin typeface="Segoe UI"/>
               </a:rPr>
-              <a:t>The one novelty claim we make, worded as narrowly as the search supports: we did not find prior use of a proof assistant on an ontology-derived anatomy hierarchy. Ten logged searches turned up no Lean, Coq or Isabelle proofs about a hierarchy built from Uberon and the Cell Ontology. That is "not found", not "does not exist", and it is not a claim to a first. Built on Uberon (10.1186/gb-2012-13-1-r5), the Cell Ontology (10.1186/2041-1480-5-21) via Ubergraph, Phenoscape (10.1093/molbev/msv223, 10.1093/sysbio/syv031) and Daane 2021 (10.1016/j.cub.2021.08.054). The anatomy terms are theirs; only the hierarchy check is ours.</a:t>
+              <a:t>All four are about fin enlargement for gliding, the trait Daane et al. 2021 measured (10.1016/j.cub.2021.08.054); the fin ratios, the convergent-substitution panel and the captured exons are theirs. Three of these close a door we would have liked open, and the one that holds, holds only inside the Beloniformes. No bird sequence, assembly or annotation was fetched: Aves is this project's frozen holdout.</a:t>
             </a:r>
           </a:p>
         </p:txBody>
@@ -10540,7 +10705,7 @@
           </a:solidFill>
           <a:ln w="12700">
             <a:solidFill>
-              <a:srgbClr val="9AA6A3"/>
+              <a:srgbClr val="EB6834"/>
             </a:solidFill>
           </a:ln>
           <a:effectLst/>
@@ -10567,10 +10732,10 @@
             <a:r>
               <a:rPr sz="900" b="1">
                 <a:solidFill>
-                  <a:srgbClr val="9AA6A3"/>
-                </a:solidFill>
-              </a:rPr>
-              <a:t>ANTICIPATED — NO DATA YET</a:t>
+                  <a:srgbClr val="EB6834"/>
+                </a:solidFill>
+              </a:rPr>
+              <a:t>PARTLY EVIDENCED</a:t>
             </a:r>
           </a:p>
         </p:txBody>
@@ -10605,54 +10770,33 @@
             <a:r>
               <a:rPr sz="4000" b="1">
                 <a:solidFill>
-                  <a:srgbClr val="9AA6A3"/>
-                </a:solidFill>
-                <a:latin typeface="Segoe UI"/>
-              </a:rPr>
-              <a:t>Where this goes next.</a:t>
-            </a:r>
-          </a:p>
-        </p:txBody>
-      </p:sp>
-      <p:sp>
-        <p:nvSpPr>
-          <p:cNvPr id="5" name="TextBox 4"/>
-          <p:cNvSpPr txBox="1"/>
-          <p:nvPr/>
-        </p:nvSpPr>
-        <p:spPr>
-          <a:xfrm>
-            <a:off x="713232" y="1920240"/>
-            <a:ext cx="8229600" cy="457200"/>
-          </a:xfrm>
-          <a:prstGeom prst="rect">
-            <a:avLst/>
-          </a:prstGeom>
-          <a:noFill/>
-        </p:spPr>
-        <p:txBody>
-          <a:bodyPr wrap="square">
-            <a:spAutoFit/>
-          </a:bodyPr>
-          <a:lstStyle/>
-          <a:p>
-            <a:pPr algn="l">
-              <a:lnSpc>
-                <a:spcPct val="100000"/>
-              </a:lnSpc>
-            </a:pPr>
-            <a:r>
-              <a:rPr sz="1500" b="0">
-                <a:solidFill>
-                  <a:srgbClr val="5A6B69"/>
-                </a:solidFill>
-                <a:latin typeface="Segoe UI"/>
-              </a:rPr>
-              <a:t>The same question at the scale of a whole organism: which genes drive fin enlargement for gliding, and by how much?</a:t>
-            </a:r>
-          </a:p>
-        </p:txBody>
-      </p:sp>
+                  <a:srgbClr val="14201F"/>
+                </a:solidFill>
+                <a:latin typeface="Segoe UI"/>
+              </a:rPr>
+              <a:t>357 named pieces. 23 measured numbers behind them.</a:t>
+            </a:r>
+          </a:p>
+        </p:txBody>
+      </p:sp>
+      <p:graphicFrame>
+        <p:nvGraphicFramePr>
+          <p:cNvPr id="5" name="Chart 4"/>
+          <p:cNvGraphicFramePr>
+            <a:graphicFrameLocks noGrp="1"/>
+          </p:cNvGraphicFramePr>
+          <p:nvPr/>
+        </p:nvGraphicFramePr>
+        <p:xfrm>
+          <a:off x="713232" y="2011680"/>
+          <a:ext cx="10490911" cy="2103120"/>
+        </p:xfrm>
+        <a:graphic>
+          <a:graphicData uri="http://schemas.openxmlformats.org/drawingml/2006/chart">
+            <c:chart xmlns:c="http://schemas.openxmlformats.org/drawingml/2006/chart" r:id="rId2"/>
+          </a:graphicData>
+        </a:graphic>
+      </p:graphicFrame>
       <p:sp>
         <p:nvSpPr>
           <p:cNvPr id="6" name="Rounded Rectangle 5"/>
@@ -10661,20 +10805,19 @@
         </p:nvSpPr>
         <p:spPr>
           <a:xfrm>
-            <a:off x="713232" y="2606040"/>
-            <a:ext cx="3401568" cy="2011680"/>
+            <a:off x="713232" y="4297680"/>
+            <a:ext cx="10765231" cy="91440"/>
           </a:xfrm>
           <a:prstGeom prst="roundRect">
             <a:avLst/>
           </a:prstGeom>
           <a:solidFill>
-            <a:srgbClr val="F2F4F3"/>
+            <a:srgbClr val="FFFFFF"/>
           </a:solidFill>
-          <a:ln w="19050">
+          <a:ln>
             <a:solidFill>
-              <a:srgbClr val="9AA6A3"/>
+              <a:srgbClr val="0E7C86"/>
             </a:solidFill>
-            <a:prstDash val="dash"/>
           </a:ln>
           <a:effectLst/>
         </p:spPr>
@@ -10693,167 +10836,27 @@
           </a:fontRef>
         </p:style>
         <p:txBody>
-          <a:bodyPr rtlCol="0" anchor="ctr" wrap="square"/>
+          <a:bodyPr rtlCol="0" anchor="ctr" wrap="square">
+            <a:spAutoFit/>
+          </a:bodyPr>
           <a:lstStyle/>
           <a:p>
             <a:pPr algn="ctr"/>
             <a:r>
-              <a:rPr sz="1400" b="1">
-                <a:solidFill>
-                  <a:srgbClr val="9AA6A3"/>
-                </a:solidFill>
-              </a:rPr>
-              <a:t>Printed flying-fish pectoral fin</a:t>
-            </a:r>
-          </a:p>
-          <a:p>
-            <a:pPr algn="ctr"/>
-            <a:r>
-              <a:rPr sz="1000">
-                <a:solidFill>
-                  <a:srgbClr val="9AA6A3"/>
-                </a:solidFill>
-              </a:rPr>
-              <a:t>no specimen, no scan, no print exists</a:t>
-            </a:r>
-          </a:p>
-        </p:txBody>
-      </p:sp>
-      <p:sp>
-        <p:nvSpPr>
-          <p:cNvPr id="7" name="Rounded Rectangle 6"/>
-          <p:cNvSpPr/>
-          <p:nvPr/>
-        </p:nvSpPr>
-        <p:spPr>
-          <a:xfrm>
-            <a:off x="4297680" y="2606040"/>
-            <a:ext cx="3401568" cy="2011680"/>
-          </a:xfrm>
-          <a:prstGeom prst="roundRect">
-            <a:avLst/>
-          </a:prstGeom>
-          <a:solidFill>
-            <a:srgbClr val="F2F4F3"/>
-          </a:solidFill>
-          <a:ln w="19050">
-            <a:solidFill>
-              <a:srgbClr val="9AA6A3"/>
-            </a:solidFill>
-            <a:prstDash val="dash"/>
-          </a:ln>
-          <a:effectLst/>
-        </p:spPr>
-        <p:style>
-          <a:lnRef idx="1">
-            <a:schemeClr val="accent1"/>
-          </a:lnRef>
-          <a:fillRef idx="3">
-            <a:schemeClr val="accent1"/>
-          </a:fillRef>
-          <a:effectRef idx="2">
-            <a:schemeClr val="accent1"/>
-          </a:effectRef>
-          <a:fontRef idx="minor">
-            <a:schemeClr val="lt1"/>
-          </a:fontRef>
-        </p:style>
-        <p:txBody>
-          <a:bodyPr rtlCol="0" anchor="ctr" wrap="square"/>
-          <a:lstStyle/>
-          <a:p>
-            <a:pPr algn="ctr"/>
-            <a:r>
-              <a:rPr sz="1400" b="1">
-                <a:solidFill>
-                  <a:srgbClr val="9AA6A3"/>
-                </a:solidFill>
-              </a:rPr>
-              <a:t>Fruit-fly wing, scaled to match</a:t>
-            </a:r>
-          </a:p>
-          <a:p>
-            <a:pPr algn="ctr"/>
-            <a:r>
-              <a:rPr sz="1000">
-                <a:solidFill>
-                  <a:srgbClr val="9AA6A3"/>
-                </a:solidFill>
-              </a:rPr>
-              <a:t>no matched control exists</a:t>
-            </a:r>
-          </a:p>
-        </p:txBody>
-      </p:sp>
-      <p:sp>
-        <p:nvSpPr>
-          <p:cNvPr id="8" name="Rounded Rectangle 7"/>
-          <p:cNvSpPr/>
-          <p:nvPr/>
-        </p:nvSpPr>
-        <p:spPr>
-          <a:xfrm>
-            <a:off x="7882128" y="2606040"/>
-            <a:ext cx="3401568" cy="2011680"/>
-          </a:xfrm>
-          <a:prstGeom prst="roundRect">
-            <a:avLst/>
-          </a:prstGeom>
-          <a:solidFill>
-            <a:srgbClr val="F2F4F3"/>
-          </a:solidFill>
-          <a:ln w="19050">
-            <a:solidFill>
-              <a:srgbClr val="9AA6A3"/>
-            </a:solidFill>
-            <a:prstDash val="dash"/>
-          </a:ln>
-          <a:effectLst/>
-        </p:spPr>
-        <p:style>
-          <a:lnRef idx="1">
-            <a:schemeClr val="accent1"/>
-          </a:lnRef>
-          <a:fillRef idx="3">
-            <a:schemeClr val="accent1"/>
-          </a:fillRef>
-          <a:effectRef idx="2">
-            <a:schemeClr val="accent1"/>
-          </a:effectRef>
-          <a:fontRef idx="minor">
-            <a:schemeClr val="lt1"/>
-          </a:fontRef>
-        </p:style>
-        <p:txBody>
-          <a:bodyPr rtlCol="0" anchor="ctr" wrap="square"/>
-          <a:lstStyle/>
-          <a:p>
-            <a:pPr algn="ctr"/>
-            <a:r>
-              <a:rPr sz="1400" b="1">
-                <a:solidFill>
-                  <a:srgbClr val="9AA6A3"/>
-                </a:solidFill>
-              </a:rPr>
-              <a:t>Which genes move which feature</a:t>
-            </a:r>
-          </a:p>
-          <a:p>
-            <a:pPr algn="ctr"/>
-            <a:r>
-              <a:rPr sz="1000">
-                <a:solidFill>
-                  <a:srgbClr val="9AA6A3"/>
-                </a:solidFill>
-              </a:rPr>
-              <a:t>no measurement, no model</a:t>
-            </a:r>
-          </a:p>
-        </p:txBody>
-      </p:sp>
-      <p:sp>
-        <p:nvSpPr>
-          <p:cNvPr id="9" name="TextBox 8"/>
+              <a:rPr sz="1100">
+                <a:solidFill>
+                  <a:srgbClr val="14201F"/>
+                </a:solidFill>
+                <a:latin typeface="Segoe UI"/>
+              </a:rPr>
+              <a:t>Evidence-backed: the flying fish rests on exactly ONE measured proportion — pectoral fin length at 0.687 of standard length, the median of 49 museum specimens, read from the measurement file rather than typed in (preserved museum specimens; length only (no fin area, shape or spread)). The two zebrafish models carry 22 sourced proportions and counts between them.   Schematic, and labelled so per piece: everything else, including every count.   Where the ontology ran out: 60 of the flying fish's pieces have no ontology term at all; the manifest records a null and the nearest ancestor it could find, instead of inventing one.</a:t>
+            </a:r>
+          </a:p>
+        </p:txBody>
+      </p:sp>
+      <p:sp>
+        <p:nvSpPr>
+          <p:cNvPr id="7" name="TextBox 6"/>
           <p:cNvSpPr txBox="1"/>
           <p:nvPr/>
         </p:nvSpPr>
@@ -10885,7 +10888,7 @@
                 </a:solidFill>
                 <a:latin typeface="Segoe UI"/>
               </a:rPr>
-              <a:t>This slide stays grey until there is something real behind it. An insect wing and a fish fin solve the same problem with unrelated parts, which makes the comparison worth running — and makes a pretty rendering easy to mistake for a result.</a:t>
+              <a:t>The one novelty claim we make, worded as narrowly as the search supports: we did not find prior use of a proof assistant on an ontology-derived anatomy hierarchy. Ten logged searches turned up no Lean, Coq or Isabelle proofs about a hierarchy built from Uberon and the Cell Ontology. That is "not found", not "does not exist", and it is not a claim to a first. Built on Uberon (10.1186/gb-2012-13-1-r5), the Cell Ontology (10.1186/2041-1480-5-21) via Ubergraph, Phenoscape (10.1093/molbev/msv223, 10.1093/sysbio/syv031) and Daane 2021 (10.1016/j.cub.2021.08.054). The anatomy terms are theirs; only the hierarchy check is ours.</a:t>
             </a:r>
           </a:p>
         </p:txBody>
@@ -10974,7 +10977,7 @@
           </a:solidFill>
           <a:ln w="12700">
             <a:solidFill>
-              <a:srgbClr val="EB6834"/>
+              <a:srgbClr val="9AA6A3"/>
             </a:solidFill>
           </a:ln>
           <a:effectLst/>
@@ -11001,10 +11004,10 @@
             <a:r>
               <a:rPr sz="900" b="1">
                 <a:solidFill>
-                  <a:srgbClr val="EB6834"/>
-                </a:solidFill>
-              </a:rPr>
-              <a:t>PARTLY EVIDENCED</a:t>
+                  <a:srgbClr val="9AA6A3"/>
+                </a:solidFill>
+              </a:rPr>
+              <a:t>ANTICIPATED — NO DATA YET</a:t>
             </a:r>
           </a:p>
         </p:txBody>
@@ -11039,75 +11042,50 @@
             <a:r>
               <a:rPr sz="4000" b="1">
                 <a:solidFill>
-                  <a:srgbClr val="14201F"/>
-                </a:solidFill>
-                <a:latin typeface="Segoe UI"/>
-              </a:rPr>
-              <a:t>The honest state of the ladder.</a:t>
-            </a:r>
-          </a:p>
-        </p:txBody>
-      </p:sp>
-      <p:sp>
-        <p:nvSpPr>
-          <p:cNvPr id="5" name="Rounded Rectangle 4"/>
-          <p:cNvSpPr/>
-          <p:nvPr/>
-        </p:nvSpPr>
-        <p:spPr>
-          <a:xfrm>
-            <a:off x="713232" y="2468880"/>
-            <a:ext cx="2103120" cy="914400"/>
-          </a:xfrm>
-          <a:prstGeom prst="roundRect">
-            <a:avLst/>
-          </a:prstGeom>
-          <a:solidFill>
-            <a:srgbClr val="FFFFFF"/>
-          </a:solidFill>
-          <a:ln>
-            <a:solidFill>
-              <a:srgbClr val="0E7C86"/>
-            </a:solidFill>
-          </a:ln>
-          <a:effectLst/>
-        </p:spPr>
-        <p:style>
-          <a:lnRef idx="1">
-            <a:schemeClr val="accent1"/>
-          </a:lnRef>
-          <a:fillRef idx="3">
-            <a:schemeClr val="accent1"/>
-          </a:fillRef>
-          <a:effectRef idx="2">
-            <a:schemeClr val="accent1"/>
-          </a:effectRef>
-          <a:fontRef idx="minor">
-            <a:schemeClr val="lt1"/>
-          </a:fontRef>
-        </p:style>
-        <p:txBody>
-          <a:bodyPr rtlCol="0" anchor="ctr"/>
-          <a:lstStyle/>
-          <a:p>
-            <a:pPr algn="ctr"/>
-            <a:r>
-              <a:rPr sz="900" b="1">
-                <a:solidFill>
-                  <a:srgbClr val="0E7C86"/>
-                </a:solidFill>
-              </a:rPr>
-              <a:t>evidenced</a:t>
-            </a:r>
-          </a:p>
-          <a:p>
-            <a:r>
-              <a:rPr sz="1300">
-                <a:solidFill>
-                  <a:srgbClr val="14201F"/>
-                </a:solidFill>
-              </a:rPr>
-              <a:t>molecule</a:t>
+                  <a:srgbClr val="9AA6A3"/>
+                </a:solidFill>
+                <a:latin typeface="Segoe UI"/>
+              </a:rPr>
+              <a:t>Where this goes next.</a:t>
+            </a:r>
+          </a:p>
+        </p:txBody>
+      </p:sp>
+      <p:sp>
+        <p:nvSpPr>
+          <p:cNvPr id="5" name="TextBox 4"/>
+          <p:cNvSpPr txBox="1"/>
+          <p:nvPr/>
+        </p:nvSpPr>
+        <p:spPr>
+          <a:xfrm>
+            <a:off x="713232" y="1920240"/>
+            <a:ext cx="8229600" cy="457200"/>
+          </a:xfrm>
+          <a:prstGeom prst="rect">
+            <a:avLst/>
+          </a:prstGeom>
+          <a:noFill/>
+        </p:spPr>
+        <p:txBody>
+          <a:bodyPr wrap="square">
+            <a:spAutoFit/>
+          </a:bodyPr>
+          <a:lstStyle/>
+          <a:p>
+            <a:pPr algn="l">
+              <a:lnSpc>
+                <a:spcPct val="100000"/>
+              </a:lnSpc>
+            </a:pPr>
+            <a:r>
+              <a:rPr sz="1500" b="0">
+                <a:solidFill>
+                  <a:srgbClr val="5A6B69"/>
+                </a:solidFill>
+                <a:latin typeface="Segoe UI"/>
+              </a:rPr>
+              <a:t>The same question at the scale of a whole organism: which genes drive fin enlargement for gliding, and by how much?</a:t>
             </a:r>
           </a:p>
         </p:txBody>
@@ -11120,16 +11098,16 @@
         </p:nvSpPr>
         <p:spPr>
           <a:xfrm>
-            <a:off x="2962656" y="2468880"/>
-            <a:ext cx="2103120" cy="914400"/>
+            <a:off x="713232" y="2606040"/>
+            <a:ext cx="3401568" cy="2011680"/>
           </a:xfrm>
           <a:prstGeom prst="roundRect">
             <a:avLst/>
           </a:prstGeom>
           <a:solidFill>
-            <a:srgbClr val="FFFFFF"/>
+            <a:srgbClr val="F2F4F3"/>
           </a:solidFill>
-          <a:ln>
+          <a:ln w="19050">
             <a:solidFill>
               <a:srgbClr val="9AA6A3"/>
             </a:solidFill>
@@ -11152,27 +11130,28 @@
           </a:fontRef>
         </p:style>
         <p:txBody>
-          <a:bodyPr rtlCol="0" anchor="ctr"/>
+          <a:bodyPr rtlCol="0" anchor="ctr" wrap="square"/>
           <a:lstStyle/>
           <a:p>
             <a:pPr algn="ctr"/>
             <a:r>
-              <a:rPr sz="900" b="1">
+              <a:rPr sz="1400" b="1">
                 <a:solidFill>
                   <a:srgbClr val="9AA6A3"/>
                 </a:solidFill>
               </a:rPr>
-              <a:t>thin</a:t>
-            </a:r>
-          </a:p>
-          <a:p>
-            <a:r>
-              <a:rPr sz="1300">
+              <a:t>Printed flying-fish pectoral fin</a:t>
+            </a:r>
+          </a:p>
+          <a:p>
+            <a:pPr algn="ctr"/>
+            <a:r>
+              <a:rPr sz="1000">
                 <a:solidFill>
                   <a:srgbClr val="9AA6A3"/>
                 </a:solidFill>
               </a:rPr>
-              <a:t>tissue</a:t>
+              <a:t>no specimen, no scan, no print exists</a:t>
             </a:r>
           </a:p>
         </p:txBody>
@@ -11185,16 +11164,16 @@
         </p:nvSpPr>
         <p:spPr>
           <a:xfrm>
-            <a:off x="5212080" y="2468880"/>
-            <a:ext cx="2103120" cy="914400"/>
+            <a:off x="4297680" y="2606040"/>
+            <a:ext cx="3401568" cy="2011680"/>
           </a:xfrm>
           <a:prstGeom prst="roundRect">
             <a:avLst/>
           </a:prstGeom>
           <a:solidFill>
-            <a:srgbClr val="FFFFFF"/>
+            <a:srgbClr val="F2F4F3"/>
           </a:solidFill>
-          <a:ln>
+          <a:ln w="19050">
             <a:solidFill>
               <a:srgbClr val="9AA6A3"/>
             </a:solidFill>
@@ -11217,27 +11196,28 @@
           </a:fontRef>
         </p:style>
         <p:txBody>
-          <a:bodyPr rtlCol="0" anchor="ctr"/>
+          <a:bodyPr rtlCol="0" anchor="ctr" wrap="square"/>
           <a:lstStyle/>
           <a:p>
             <a:pPr algn="ctr"/>
             <a:r>
-              <a:rPr sz="900" b="1">
+              <a:rPr sz="1400" b="1">
                 <a:solidFill>
                   <a:srgbClr val="9AA6A3"/>
                 </a:solidFill>
               </a:rPr>
-              <a:t>thin</a:t>
-            </a:r>
-          </a:p>
-          <a:p>
-            <a:r>
-              <a:rPr sz="1300">
+              <a:t>Fruit-fly wing, scaled to match</a:t>
+            </a:r>
+          </a:p>
+          <a:p>
+            <a:pPr algn="ctr"/>
+            <a:r>
+              <a:rPr sz="1000">
                 <a:solidFill>
                   <a:srgbClr val="9AA6A3"/>
                 </a:solidFill>
               </a:rPr>
-              <a:t>organ</a:t>
+              <a:t>no matched control exists</a:t>
             </a:r>
           </a:p>
         </p:txBody>
@@ -11250,16 +11230,16 @@
         </p:nvSpPr>
         <p:spPr>
           <a:xfrm>
-            <a:off x="7461504" y="2468880"/>
-            <a:ext cx="2103120" cy="914400"/>
+            <a:off x="7882128" y="2606040"/>
+            <a:ext cx="3401568" cy="2011680"/>
           </a:xfrm>
           <a:prstGeom prst="roundRect">
             <a:avLst/>
           </a:prstGeom>
           <a:solidFill>
-            <a:srgbClr val="FFFFFF"/>
+            <a:srgbClr val="F2F4F3"/>
           </a:solidFill>
-          <a:ln>
+          <a:ln w="19050">
             <a:solidFill>
               <a:srgbClr val="9AA6A3"/>
             </a:solidFill>
@@ -11282,98 +11262,35 @@
           </a:fontRef>
         </p:style>
         <p:txBody>
-          <a:bodyPr rtlCol="0" anchor="ctr"/>
+          <a:bodyPr rtlCol="0" anchor="ctr" wrap="square"/>
           <a:lstStyle/>
           <a:p>
             <a:pPr algn="ctr"/>
             <a:r>
-              <a:rPr sz="900" b="1">
+              <a:rPr sz="1400" b="1">
                 <a:solidFill>
                   <a:srgbClr val="9AA6A3"/>
                 </a:solidFill>
               </a:rPr>
-              <a:t>thin</a:t>
-            </a:r>
-          </a:p>
-          <a:p>
-            <a:r>
-              <a:rPr sz="1300">
+              <a:t>Which genes move which feature</a:t>
+            </a:r>
+          </a:p>
+          <a:p>
+            <a:pPr algn="ctr"/>
+            <a:r>
+              <a:rPr sz="1000">
                 <a:solidFill>
                   <a:srgbClr val="9AA6A3"/>
                 </a:solidFill>
               </a:rPr>
-              <a:t>whole organism</a:t>
-            </a:r>
-          </a:p>
-        </p:txBody>
-      </p:sp>
-      <p:sp>
-        <p:nvSpPr>
-          <p:cNvPr id="9" name="Rounded Rectangle 8"/>
-          <p:cNvSpPr/>
-          <p:nvPr/>
-        </p:nvSpPr>
-        <p:spPr>
-          <a:xfrm>
-            <a:off x="9710928" y="2468880"/>
-            <a:ext cx="2103120" cy="914400"/>
-          </a:xfrm>
-          <a:prstGeom prst="roundRect">
-            <a:avLst/>
-          </a:prstGeom>
-          <a:solidFill>
-            <a:srgbClr val="FFFFFF"/>
-          </a:solidFill>
-          <a:ln>
-            <a:solidFill>
-              <a:srgbClr val="0E7C86"/>
-            </a:solidFill>
-          </a:ln>
-          <a:effectLst/>
-        </p:spPr>
-        <p:style>
-          <a:lnRef idx="1">
-            <a:schemeClr val="accent1"/>
-          </a:lnRef>
-          <a:fillRef idx="3">
-            <a:schemeClr val="accent1"/>
-          </a:fillRef>
-          <a:effectRef idx="2">
-            <a:schemeClr val="accent1"/>
-          </a:effectRef>
-          <a:fontRef idx="minor">
-            <a:schemeClr val="lt1"/>
-          </a:fontRef>
-        </p:style>
-        <p:txBody>
-          <a:bodyPr rtlCol="0" anchor="ctr"/>
-          <a:lstStyle/>
-          <a:p>
-            <a:pPr algn="ctr"/>
-            <a:r>
-              <a:rPr sz="900" b="1">
-                <a:solidFill>
-                  <a:srgbClr val="0E7C86"/>
-                </a:solidFill>
-              </a:rPr>
-              <a:t>evidenced</a:t>
-            </a:r>
-          </a:p>
-          <a:p>
-            <a:r>
-              <a:rPr sz="1300">
-                <a:solidFill>
-                  <a:srgbClr val="14201F"/>
-                </a:solidFill>
-              </a:rPr>
-              <a:t>population</a:t>
-            </a:r>
-          </a:p>
-        </p:txBody>
-      </p:sp>
-      <p:sp>
-        <p:nvSpPr>
-          <p:cNvPr id="10" name="TextBox 9"/>
+              <a:t>no measurement, no model</a:t>
+            </a:r>
+          </a:p>
+        </p:txBody>
+      </p:sp>
+      <p:sp>
+        <p:nvSpPr>
+          <p:cNvPr id="9" name="TextBox 8"/>
           <p:cNvSpPr txBox="1"/>
           <p:nvPr/>
         </p:nvSpPr>
@@ -11405,7 +11322,7 @@
                 </a:solidFill>
                 <a:latin typeface="Segoe UI"/>
               </a:rPr>
-              <a:t>We can go from a sequence to a measured growth rate, and from a claim to a population-level test. The middle of the ladder is where the data thins out, and we are not going to pretend otherwise: the species with a complete record at every scale is a short list, and we publish its length rather than loosening the definition.</a:t>
+              <a:t>This slide stays grey until there is something real behind it. An insect wing and a fish fin solve the same problem with unrelated parts, which makes the comparison worth running — and makes a pretty rendering easy to mistake for a result.</a:t>
             </a:r>
           </a:p>
         </p:txBody>
@@ -11563,110 +11480,337 @@
                 </a:solidFill>
                 <a:latin typeface="Segoe UI"/>
               </a:rPr>
-              <a:t>Every finding, made citable.</a:t>
-            </a:r>
-          </a:p>
-        </p:txBody>
-      </p:sp>
-      <p:graphicFrame>
-        <p:nvGraphicFramePr>
-          <p:cNvPr id="5" name="Chart 4"/>
-          <p:cNvGraphicFramePr>
-            <a:graphicFrameLocks noGrp="1"/>
-          </p:cNvGraphicFramePr>
-          <p:nvPr/>
-        </p:nvGraphicFramePr>
-        <p:xfrm>
-          <a:off x="713232" y="1965960"/>
-          <a:ext cx="10490911" cy="2286000"/>
-        </p:xfrm>
-        <a:graphic>
-          <a:graphicData uri="http://schemas.openxmlformats.org/drawingml/2006/chart">
-            <c:chart xmlns:c="http://schemas.openxmlformats.org/drawingml/2006/chart" r:id="rId2"/>
-          </a:graphicData>
-        </a:graphic>
-      </p:graphicFrame>
-      <p:sp>
-        <p:nvSpPr>
-          <p:cNvPr id="6" name="TextBox 5"/>
-          <p:cNvSpPr txBox="1"/>
-          <p:nvPr/>
-        </p:nvSpPr>
-        <p:spPr>
-          <a:xfrm>
-            <a:off x="713232" y="4389120"/>
-            <a:ext cx="5120640" cy="822960"/>
-          </a:xfrm>
-          <a:prstGeom prst="rect">
-            <a:avLst/>
-          </a:prstGeom>
-          <a:noFill/>
-        </p:spPr>
-        <p:txBody>
-          <a:bodyPr wrap="square">
-            <a:spAutoFit/>
-          </a:bodyPr>
-          <a:lstStyle/>
-          <a:p>
-            <a:pPr algn="l">
-              <a:lnSpc>
-                <a:spcPct val="100000"/>
-              </a:lnSpc>
-            </a:pPr>
-            <a:r>
-              <a:rPr sz="2600" b="1">
-                <a:solidFill>
-                  <a:srgbClr val="1BAF7A"/>
-                </a:solidFill>
-                <a:latin typeface="Segoe UI"/>
-              </a:rPr>
-              <a:t>158 records drafted and validated</a:t>
-            </a:r>
-          </a:p>
-        </p:txBody>
-      </p:sp>
-      <p:sp>
-        <p:nvSpPr>
-          <p:cNvPr id="7" name="TextBox 6"/>
-          <p:cNvSpPr txBox="1"/>
-          <p:nvPr/>
-        </p:nvSpPr>
-        <p:spPr>
-          <a:xfrm>
-            <a:off x="6199632" y="4389120"/>
-            <a:ext cx="5120640" cy="822960"/>
-          </a:xfrm>
-          <a:prstGeom prst="rect">
-            <a:avLst/>
-          </a:prstGeom>
-          <a:noFill/>
-        </p:spPr>
-        <p:txBody>
-          <a:bodyPr wrap="square">
-            <a:spAutoFit/>
-          </a:bodyPr>
-          <a:lstStyle/>
-          <a:p>
-            <a:pPr algn="l">
-              <a:lnSpc>
-                <a:spcPct val="100000"/>
-              </a:lnSpc>
-            </a:pPr>
-            <a:r>
-              <a:rPr sz="2600" b="1">
+              <a:t>The honest state of the ladder.</a:t>
+            </a:r>
+          </a:p>
+        </p:txBody>
+      </p:sp>
+      <p:sp>
+        <p:nvSpPr>
+          <p:cNvPr id="5" name="Rounded Rectangle 4"/>
+          <p:cNvSpPr/>
+          <p:nvPr/>
+        </p:nvSpPr>
+        <p:spPr>
+          <a:xfrm>
+            <a:off x="713232" y="2468880"/>
+            <a:ext cx="2103120" cy="914400"/>
+          </a:xfrm>
+          <a:prstGeom prst="roundRect">
+            <a:avLst/>
+          </a:prstGeom>
+          <a:solidFill>
+            <a:srgbClr val="FFFFFF"/>
+          </a:solidFill>
+          <a:ln>
+            <a:solidFill>
+              <a:srgbClr val="0E7C86"/>
+            </a:solidFill>
+          </a:ln>
+          <a:effectLst/>
+        </p:spPr>
+        <p:style>
+          <a:lnRef idx="1">
+            <a:schemeClr val="accent1"/>
+          </a:lnRef>
+          <a:fillRef idx="3">
+            <a:schemeClr val="accent1"/>
+          </a:fillRef>
+          <a:effectRef idx="2">
+            <a:schemeClr val="accent1"/>
+          </a:effectRef>
+          <a:fontRef idx="minor">
+            <a:schemeClr val="lt1"/>
+          </a:fontRef>
+        </p:style>
+        <p:txBody>
+          <a:bodyPr rtlCol="0" anchor="ctr"/>
+          <a:lstStyle/>
+          <a:p>
+            <a:pPr algn="ctr"/>
+            <a:r>
+              <a:rPr sz="900" b="1">
+                <a:solidFill>
+                  <a:srgbClr val="0E7C86"/>
+                </a:solidFill>
+              </a:rPr>
+              <a:t>evidenced</a:t>
+            </a:r>
+          </a:p>
+          <a:p>
+            <a:r>
+              <a:rPr sz="1300">
+                <a:solidFill>
+                  <a:srgbClr val="14201F"/>
+                </a:solidFill>
+              </a:rPr>
+              <a:t>molecule</a:t>
+            </a:r>
+          </a:p>
+        </p:txBody>
+      </p:sp>
+      <p:sp>
+        <p:nvSpPr>
+          <p:cNvPr id="6" name="Rounded Rectangle 5"/>
+          <p:cNvSpPr/>
+          <p:nvPr/>
+        </p:nvSpPr>
+        <p:spPr>
+          <a:xfrm>
+            <a:off x="2962656" y="2468880"/>
+            <a:ext cx="2103120" cy="914400"/>
+          </a:xfrm>
+          <a:prstGeom prst="roundRect">
+            <a:avLst/>
+          </a:prstGeom>
+          <a:solidFill>
+            <a:srgbClr val="FFFFFF"/>
+          </a:solidFill>
+          <a:ln>
+            <a:solidFill>
+              <a:srgbClr val="9AA6A3"/>
+            </a:solidFill>
+            <a:prstDash val="dash"/>
+          </a:ln>
+          <a:effectLst/>
+        </p:spPr>
+        <p:style>
+          <a:lnRef idx="1">
+            <a:schemeClr val="accent1"/>
+          </a:lnRef>
+          <a:fillRef idx="3">
+            <a:schemeClr val="accent1"/>
+          </a:fillRef>
+          <a:effectRef idx="2">
+            <a:schemeClr val="accent1"/>
+          </a:effectRef>
+          <a:fontRef idx="minor">
+            <a:schemeClr val="lt1"/>
+          </a:fontRef>
+        </p:style>
+        <p:txBody>
+          <a:bodyPr rtlCol="0" anchor="ctr"/>
+          <a:lstStyle/>
+          <a:p>
+            <a:pPr algn="ctr"/>
+            <a:r>
+              <a:rPr sz="900" b="1">
                 <a:solidFill>
                   <a:srgbClr val="9AA6A3"/>
                 </a:solidFill>
-                <a:latin typeface="Segoe UI"/>
-              </a:rPr>
-              <a:t>0 signed — publishing is irreversible</a:t>
-            </a:r>
-          </a:p>
-        </p:txBody>
-      </p:sp>
-      <p:sp>
-        <p:nvSpPr>
-          <p:cNvPr id="8" name="TextBox 7"/>
+              </a:rPr>
+              <a:t>thin</a:t>
+            </a:r>
+          </a:p>
+          <a:p>
+            <a:r>
+              <a:rPr sz="1300">
+                <a:solidFill>
+                  <a:srgbClr val="9AA6A3"/>
+                </a:solidFill>
+              </a:rPr>
+              <a:t>tissue</a:t>
+            </a:r>
+          </a:p>
+        </p:txBody>
+      </p:sp>
+      <p:sp>
+        <p:nvSpPr>
+          <p:cNvPr id="7" name="Rounded Rectangle 6"/>
+          <p:cNvSpPr/>
+          <p:nvPr/>
+        </p:nvSpPr>
+        <p:spPr>
+          <a:xfrm>
+            <a:off x="5212080" y="2468880"/>
+            <a:ext cx="2103120" cy="914400"/>
+          </a:xfrm>
+          <a:prstGeom prst="roundRect">
+            <a:avLst/>
+          </a:prstGeom>
+          <a:solidFill>
+            <a:srgbClr val="FFFFFF"/>
+          </a:solidFill>
+          <a:ln>
+            <a:solidFill>
+              <a:srgbClr val="9AA6A3"/>
+            </a:solidFill>
+            <a:prstDash val="dash"/>
+          </a:ln>
+          <a:effectLst/>
+        </p:spPr>
+        <p:style>
+          <a:lnRef idx="1">
+            <a:schemeClr val="accent1"/>
+          </a:lnRef>
+          <a:fillRef idx="3">
+            <a:schemeClr val="accent1"/>
+          </a:fillRef>
+          <a:effectRef idx="2">
+            <a:schemeClr val="accent1"/>
+          </a:effectRef>
+          <a:fontRef idx="minor">
+            <a:schemeClr val="lt1"/>
+          </a:fontRef>
+        </p:style>
+        <p:txBody>
+          <a:bodyPr rtlCol="0" anchor="ctr"/>
+          <a:lstStyle/>
+          <a:p>
+            <a:pPr algn="ctr"/>
+            <a:r>
+              <a:rPr sz="900" b="1">
+                <a:solidFill>
+                  <a:srgbClr val="9AA6A3"/>
+                </a:solidFill>
+              </a:rPr>
+              <a:t>thin</a:t>
+            </a:r>
+          </a:p>
+          <a:p>
+            <a:r>
+              <a:rPr sz="1300">
+                <a:solidFill>
+                  <a:srgbClr val="9AA6A3"/>
+                </a:solidFill>
+              </a:rPr>
+              <a:t>organ</a:t>
+            </a:r>
+          </a:p>
+        </p:txBody>
+      </p:sp>
+      <p:sp>
+        <p:nvSpPr>
+          <p:cNvPr id="8" name="Rounded Rectangle 7"/>
+          <p:cNvSpPr/>
+          <p:nvPr/>
+        </p:nvSpPr>
+        <p:spPr>
+          <a:xfrm>
+            <a:off x="7461504" y="2468880"/>
+            <a:ext cx="2103120" cy="914400"/>
+          </a:xfrm>
+          <a:prstGeom prst="roundRect">
+            <a:avLst/>
+          </a:prstGeom>
+          <a:solidFill>
+            <a:srgbClr val="FFFFFF"/>
+          </a:solidFill>
+          <a:ln>
+            <a:solidFill>
+              <a:srgbClr val="9AA6A3"/>
+            </a:solidFill>
+            <a:prstDash val="dash"/>
+          </a:ln>
+          <a:effectLst/>
+        </p:spPr>
+        <p:style>
+          <a:lnRef idx="1">
+            <a:schemeClr val="accent1"/>
+          </a:lnRef>
+          <a:fillRef idx="3">
+            <a:schemeClr val="accent1"/>
+          </a:fillRef>
+          <a:effectRef idx="2">
+            <a:schemeClr val="accent1"/>
+          </a:effectRef>
+          <a:fontRef idx="minor">
+            <a:schemeClr val="lt1"/>
+          </a:fontRef>
+        </p:style>
+        <p:txBody>
+          <a:bodyPr rtlCol="0" anchor="ctr"/>
+          <a:lstStyle/>
+          <a:p>
+            <a:pPr algn="ctr"/>
+            <a:r>
+              <a:rPr sz="900" b="1">
+                <a:solidFill>
+                  <a:srgbClr val="9AA6A3"/>
+                </a:solidFill>
+              </a:rPr>
+              <a:t>thin</a:t>
+            </a:r>
+          </a:p>
+          <a:p>
+            <a:r>
+              <a:rPr sz="1300">
+                <a:solidFill>
+                  <a:srgbClr val="9AA6A3"/>
+                </a:solidFill>
+              </a:rPr>
+              <a:t>whole organism</a:t>
+            </a:r>
+          </a:p>
+        </p:txBody>
+      </p:sp>
+      <p:sp>
+        <p:nvSpPr>
+          <p:cNvPr id="9" name="Rounded Rectangle 8"/>
+          <p:cNvSpPr/>
+          <p:nvPr/>
+        </p:nvSpPr>
+        <p:spPr>
+          <a:xfrm>
+            <a:off x="9710928" y="2468880"/>
+            <a:ext cx="2103120" cy="914400"/>
+          </a:xfrm>
+          <a:prstGeom prst="roundRect">
+            <a:avLst/>
+          </a:prstGeom>
+          <a:solidFill>
+            <a:srgbClr val="FFFFFF"/>
+          </a:solidFill>
+          <a:ln>
+            <a:solidFill>
+              <a:srgbClr val="0E7C86"/>
+            </a:solidFill>
+          </a:ln>
+          <a:effectLst/>
+        </p:spPr>
+        <p:style>
+          <a:lnRef idx="1">
+            <a:schemeClr val="accent1"/>
+          </a:lnRef>
+          <a:fillRef idx="3">
+            <a:schemeClr val="accent1"/>
+          </a:fillRef>
+          <a:effectRef idx="2">
+            <a:schemeClr val="accent1"/>
+          </a:effectRef>
+          <a:fontRef idx="minor">
+            <a:schemeClr val="lt1"/>
+          </a:fontRef>
+        </p:style>
+        <p:txBody>
+          <a:bodyPr rtlCol="0" anchor="ctr"/>
+          <a:lstStyle/>
+          <a:p>
+            <a:pPr algn="ctr"/>
+            <a:r>
+              <a:rPr sz="900" b="1">
+                <a:solidFill>
+                  <a:srgbClr val="0E7C86"/>
+                </a:solidFill>
+              </a:rPr>
+              <a:t>evidenced</a:t>
+            </a:r>
+          </a:p>
+          <a:p>
+            <a:r>
+              <a:rPr sz="1300">
+                <a:solidFill>
+                  <a:srgbClr val="14201F"/>
+                </a:solidFill>
+              </a:rPr>
+              <a:t>population</a:t>
+            </a:r>
+          </a:p>
+        </p:txBody>
+      </p:sp>
+      <p:sp>
+        <p:nvSpPr>
+          <p:cNvPr id="10" name="TextBox 9"/>
           <p:cNvSpPr txBox="1"/>
           <p:nvPr/>
         </p:nvSpPr>
@@ -11698,7 +11842,7 @@
                 </a:solidFill>
                 <a:latin typeface="Segoe UI"/>
               </a:rPr>
-              <a:t>Each record carries the claim in one sentence, its status including refuted and inconclusive, the dataset with its identifier, the commit proving the test predated the data, and what it does not establish. Refutations are published too; publishing only successes builds a victory log. While drafting we found the published templates use a retired vocabulary, so declaring one would have asserted something false about how every record was made — dropped, measured across five templates, and reported upstream.</a:t>
+              <a:t>We can go from a sequence to a measured growth rate, and from a claim to a population-level test. The middle of the ladder is where the data thins out, and we are not going to pretend otherwise: the species with a complete record at every scale is a short list, and we publish its length rather than loosening the definition.</a:t>
             </a:r>
           </a:p>
         </p:txBody>
@@ -11787,7 +11931,7 @@
           </a:solidFill>
           <a:ln w="12700">
             <a:solidFill>
-              <a:srgbClr val="1BAF7A"/>
+              <a:srgbClr val="EB6834"/>
             </a:solidFill>
           </a:ln>
           <a:effectLst/>
@@ -11814,10 +11958,10 @@
             <a:r>
               <a:rPr sz="900" b="1">
                 <a:solidFill>
-                  <a:srgbClr val="1BAF7A"/>
-                </a:solidFill>
-              </a:rPr>
-              <a:t>EVIDENCE IN HAND</a:t>
+                  <a:srgbClr val="EB6834"/>
+                </a:solidFill>
+              </a:rPr>
+              <a:t>PARTLY EVIDENCED</a:t>
             </a:r>
           </a:p>
         </p:txBody>
@@ -11856,21 +12000,39 @@
                 </a:solidFill>
                 <a:latin typeface="Segoe UI"/>
               </a:rPr>
-              <a:t>What we are not claiming.</a:t>
-            </a:r>
-          </a:p>
-        </p:txBody>
-      </p:sp>
-      <p:sp>
-        <p:nvSpPr>
-          <p:cNvPr id="5" name="TextBox 4"/>
-          <p:cNvSpPr txBox="1"/>
-          <p:nvPr/>
-        </p:nvSpPr>
-        <p:spPr>
-          <a:xfrm>
-            <a:off x="713232" y="2148840"/>
-            <a:ext cx="10765231" cy="731520"/>
+              <a:t>Every finding, made citable.</a:t>
+            </a:r>
+          </a:p>
+        </p:txBody>
+      </p:sp>
+      <p:graphicFrame>
+        <p:nvGraphicFramePr>
+          <p:cNvPr id="5" name="Chart 4"/>
+          <p:cNvGraphicFramePr>
+            <a:graphicFrameLocks noGrp="1"/>
+          </p:cNvGraphicFramePr>
+          <p:nvPr/>
+        </p:nvGraphicFramePr>
+        <p:xfrm>
+          <a:off x="713232" y="1965960"/>
+          <a:ext cx="10490911" cy="2286000"/>
+        </p:xfrm>
+        <a:graphic>
+          <a:graphicData uri="http://schemas.openxmlformats.org/drawingml/2006/chart">
+            <c:chart xmlns:c="http://schemas.openxmlformats.org/drawingml/2006/chart" r:id="rId2"/>
+          </a:graphicData>
+        </a:graphic>
+      </p:graphicFrame>
+      <p:sp>
+        <p:nvSpPr>
+          <p:cNvPr id="6" name="TextBox 5"/>
+          <p:cNvSpPr txBox="1"/>
+          <p:nvPr/>
+        </p:nvSpPr>
+        <p:spPr>
+          <a:xfrm>
+            <a:off x="713232" y="4389120"/>
+            <a:ext cx="5120640" cy="822960"/>
           </a:xfrm>
           <a:prstGeom prst="rect">
             <a:avLst/>
@@ -11885,31 +12047,31 @@
           <a:p>
             <a:pPr algn="l">
               <a:lnSpc>
-                <a:spcPct val="115000"/>
-              </a:lnSpc>
-            </a:pPr>
-            <a:r>
-              <a:rPr sz="1300" b="0">
-                <a:solidFill>
-                  <a:srgbClr val="14201F"/>
-                </a:solidFill>
-                <a:latin typeface="Segoe UI"/>
-              </a:rPr>
-              <a:t>—  No wet lab. Nothing here was measured at a bench by us; no new organism, protein or variant was made.</a:t>
-            </a:r>
-          </a:p>
-        </p:txBody>
-      </p:sp>
-      <p:sp>
-        <p:nvSpPr>
-          <p:cNvPr id="6" name="TextBox 5"/>
-          <p:cNvSpPr txBox="1"/>
-          <p:nvPr/>
-        </p:nvSpPr>
-        <p:spPr>
-          <a:xfrm>
-            <a:off x="713232" y="2898648"/>
-            <a:ext cx="10765231" cy="731520"/>
+                <a:spcPct val="100000"/>
+              </a:lnSpc>
+            </a:pPr>
+            <a:r>
+              <a:rPr sz="2600" b="1">
+                <a:solidFill>
+                  <a:srgbClr val="1BAF7A"/>
+                </a:solidFill>
+                <a:latin typeface="Segoe UI"/>
+              </a:rPr>
+              <a:t>158 records drafted and validated</a:t>
+            </a:r>
+          </a:p>
+        </p:txBody>
+      </p:sp>
+      <p:sp>
+        <p:nvSpPr>
+          <p:cNvPr id="7" name="TextBox 6"/>
+          <p:cNvSpPr txBox="1"/>
+          <p:nvPr/>
+        </p:nvSpPr>
+        <p:spPr>
+          <a:xfrm>
+            <a:off x="6199632" y="4389120"/>
+            <a:ext cx="5120640" cy="822960"/>
           </a:xfrm>
           <a:prstGeom prst="rect">
             <a:avLst/>
@@ -11924,56 +12086,17 @@
           <a:p>
             <a:pPr algn="l">
               <a:lnSpc>
-                <a:spcPct val="115000"/>
-              </a:lnSpc>
-            </a:pPr>
-            <a:r>
-              <a:rPr sz="1300" b="0">
-                <a:solidFill>
-                  <a:srgbClr val="14201F"/>
-                </a:solidFill>
-                <a:latin typeface="Segoe UI"/>
-              </a:rPr>
-              <a:t>—  No proof about biology. The machine checked the reasoning from measurements to a safe route. That the measurements bracket the truth is assumed, and two replicates cannot justify it across 159,129 variants.</a:t>
-            </a:r>
-          </a:p>
-        </p:txBody>
-      </p:sp>
-      <p:sp>
-        <p:nvSpPr>
-          <p:cNvPr id="7" name="TextBox 6"/>
-          <p:cNvSpPr txBox="1"/>
-          <p:nvPr/>
-        </p:nvSpPr>
-        <p:spPr>
-          <a:xfrm>
-            <a:off x="713232" y="3648456"/>
-            <a:ext cx="10765231" cy="731520"/>
-          </a:xfrm>
-          <a:prstGeom prst="rect">
-            <a:avLst/>
-          </a:prstGeom>
-          <a:noFill/>
-        </p:spPr>
-        <p:txBody>
-          <a:bodyPr wrap="square">
-            <a:spAutoFit/>
-          </a:bodyPr>
-          <a:lstStyle/>
-          <a:p>
-            <a:pPr algn="l">
-              <a:lnSpc>
-                <a:spcPct val="115000"/>
-              </a:lnSpc>
-            </a:pPr>
-            <a:r>
-              <a:rPr sz="1300" b="0">
-                <a:solidFill>
-                  <a:srgbClr val="14201F"/>
-                </a:solidFill>
-                <a:latin typeface="Segoe UI"/>
-              </a:rPr>
-              <a:t>—  "Blocked" is not "impossible." It means unreachable in the measured four-position graph, never in biology.</a:t>
+                <a:spcPct val="100000"/>
+              </a:lnSpc>
+            </a:pPr>
+            <a:r>
+              <a:rPr sz="2600" b="1">
+                <a:solidFill>
+                  <a:srgbClr val="9AA6A3"/>
+                </a:solidFill>
+                <a:latin typeface="Segoe UI"/>
+              </a:rPr>
+              <a:t>0 signed — publishing is irreversible</a:t>
             </a:r>
           </a:p>
         </p:txBody>
@@ -11981,201 +12104,6 @@
       <p:sp>
         <p:nvSpPr>
           <p:cNvPr id="8" name="TextBox 7"/>
-          <p:cNvSpPr txBox="1"/>
-          <p:nvPr/>
-        </p:nvSpPr>
-        <p:spPr>
-          <a:xfrm>
-            <a:off x="713232" y="4398264"/>
-            <a:ext cx="10765231" cy="731520"/>
-          </a:xfrm>
-          <a:prstGeom prst="rect">
-            <a:avLst/>
-          </a:prstGeom>
-          <a:noFill/>
-        </p:spPr>
-        <p:txBody>
-          <a:bodyPr wrap="square">
-            <a:spAutoFit/>
-          </a:bodyPr>
-          <a:lstStyle/>
-          <a:p>
-            <a:pPr algn="l">
-              <a:lnSpc>
-                <a:spcPct val="115000"/>
-              </a:lnSpc>
-            </a:pPr>
-            <a:r>
-              <a:rPr sz="1300" b="0">
-                <a:solidFill>
-                  <a:srgbClr val="14201F"/>
-                </a:solidFill>
-                <a:latin typeface="Segoe UI"/>
-              </a:rPr>
-              <a:t>—  The publications are unsigned drafts. Valid, unpublished, and described as drafts.</a:t>
-            </a:r>
-          </a:p>
-        </p:txBody>
-      </p:sp>
-      <p:sp>
-        <p:nvSpPr>
-          <p:cNvPr id="9" name="TextBox 8"/>
-          <p:cNvSpPr txBox="1"/>
-          <p:nvPr/>
-        </p:nvSpPr>
-        <p:spPr>
-          <a:xfrm>
-            <a:off x="713232" y="5148072"/>
-            <a:ext cx="10765231" cy="731520"/>
-          </a:xfrm>
-          <a:prstGeom prst="rect">
-            <a:avLst/>
-          </a:prstGeom>
-          <a:noFill/>
-        </p:spPr>
-        <p:txBody>
-          <a:bodyPr wrap="square">
-            <a:spAutoFit/>
-          </a:bodyPr>
-          <a:lstStyle/>
-          <a:p>
-            <a:pPr algn="l">
-              <a:lnSpc>
-                <a:spcPct val="115000"/>
-              </a:lnSpc>
-            </a:pPr>
-            <a:r>
-              <a:rPr sz="1300" b="0">
-                <a:solidFill>
-                  <a:srgbClr val="14201F"/>
-                </a:solidFill>
-                <a:latin typeface="Segoe UI"/>
-              </a:rPr>
-              <a:t>—  4 of 5 outside numbers reproduced exactly; the one we could not check, we said so rather than fill in.</a:t>
-            </a:r>
-          </a:p>
-        </p:txBody>
-      </p:sp>
-      <p:sp>
-        <p:nvSpPr>
-          <p:cNvPr id="10" name="TextBox 9"/>
-          <p:cNvSpPr txBox="1"/>
-          <p:nvPr/>
-        </p:nvSpPr>
-        <p:spPr>
-          <a:xfrm>
-            <a:off x="713232" y="5897880"/>
-            <a:ext cx="10765231" cy="731520"/>
-          </a:xfrm>
-          <a:prstGeom prst="rect">
-            <a:avLst/>
-          </a:prstGeom>
-          <a:noFill/>
-        </p:spPr>
-        <p:txBody>
-          <a:bodyPr wrap="square">
-            <a:spAutoFit/>
-          </a:bodyPr>
-          <a:lstStyle/>
-          <a:p>
-            <a:pPr algn="l">
-              <a:lnSpc>
-                <a:spcPct val="115000"/>
-              </a:lnSpc>
-            </a:pPr>
-            <a:r>
-              <a:rPr sz="1300" b="0">
-                <a:solidFill>
-                  <a:srgbClr val="14201F"/>
-                </a:solidFill>
-                <a:latin typeface="Segoe UI"/>
-              </a:rPr>
-              <a:t>—  4 of our own claims were corrected in one day — 3 found by our own checks, 1 by a collaborator's independent cross-check. Each was withdrawn or narrowed in public, as a record or a log entry, never as a silent edit.</a:t>
-            </a:r>
-          </a:p>
-        </p:txBody>
-      </p:sp>
-      <p:sp>
-        <p:nvSpPr>
-          <p:cNvPr id="11" name="TextBox 10"/>
-          <p:cNvSpPr txBox="1"/>
-          <p:nvPr/>
-        </p:nvSpPr>
-        <p:spPr>
-          <a:xfrm>
-            <a:off x="713232" y="6647688"/>
-            <a:ext cx="10765231" cy="731520"/>
-          </a:xfrm>
-          <a:prstGeom prst="rect">
-            <a:avLst/>
-          </a:prstGeom>
-          <a:noFill/>
-        </p:spPr>
-        <p:txBody>
-          <a:bodyPr wrap="square">
-            <a:spAutoFit/>
-          </a:bodyPr>
-          <a:lstStyle/>
-          <a:p>
-            <a:pPr algn="l">
-              <a:lnSpc>
-                <a:spcPct val="115000"/>
-              </a:lnSpc>
-            </a:pPr>
-            <a:r>
-              <a:rPr sz="1300" b="0">
-                <a:solidFill>
-                  <a:srgbClr val="14201F"/>
-                </a:solidFill>
-                <a:latin typeface="Segoe UI"/>
-              </a:rPr>
-              <a:t>—  We did not design an organism. The "designed" fish is Daane et al. 2021's published double heterozygote, and our pre-registered test of it came back unsupported. The apparatus is ours; the animal is not.</a:t>
-            </a:r>
-          </a:p>
-        </p:txBody>
-      </p:sp>
-      <p:sp>
-        <p:nvSpPr>
-          <p:cNvPr id="12" name="TextBox 11"/>
-          <p:cNvSpPr txBox="1"/>
-          <p:nvPr/>
-        </p:nvSpPr>
-        <p:spPr>
-          <a:xfrm>
-            <a:off x="713232" y="7397496"/>
-            <a:ext cx="10765231" cy="731520"/>
-          </a:xfrm>
-          <a:prstGeom prst="rect">
-            <a:avLst/>
-          </a:prstGeom>
-          <a:noFill/>
-        </p:spPr>
-        <p:txBody>
-          <a:bodyPr wrap="square">
-            <a:spAutoFit/>
-          </a:bodyPr>
-          <a:lstStyle/>
-          <a:p>
-            <a:pPr algn="l">
-              <a:lnSpc>
-                <a:spcPct val="115000"/>
-              </a:lnSpc>
-            </a:pPr>
-            <a:r>
-              <a:rPr sz="1300" b="0">
-                <a:solidFill>
-                  <a:srgbClr val="14201F"/>
-                </a:solidFill>
-                <a:latin typeface="Segoe UI"/>
-              </a:rPr>
-              <a:t>—  Validation on unseen data ran, and returned nothing. A clade was frozen as a holdout before the tests were built; 3 completed results were examined against it and 3 came back inconclusive. The 2 that state a reason were stopped by the builders' own pre-registered minimum sample size, not by a verdict we disliked. An exam that cannot reach a verdict is reported as one that cannot.</a:t>
-            </a:r>
-          </a:p>
-        </p:txBody>
-      </p:sp>
-      <p:sp>
-        <p:nvSpPr>
-          <p:cNvPr id="13" name="TextBox 12"/>
           <p:cNvSpPr txBox="1"/>
           <p:nvPr/>
         </p:nvSpPr>
@@ -12207,7 +12135,7 @@
                 </a:solidFill>
                 <a:latin typeface="Segoe UI"/>
               </a:rPr>
-              <a:t>Every one of these is on the public dashboard too, next to the result it limits.</a:t>
+              <a:t>Each record carries the claim in one sentence, its status including refuted and inconclusive, the dataset with its identifier, the commit proving the test predated the data, and what it does not establish. Refutations are published too; publishing only successes builds a victory log. While drafting we found the published templates use a retired vocabulary, so declaring one would have asserted something false about how every record was made — dropped, measured across five templates, and reported upstream.</a:t>
             </a:r>
           </a:p>
         </p:txBody>
@@ -12221,6 +12149,515 @@
 </file>
 
 <file path=ppt/slides/slide24.xml><?xml version="1.0" encoding="utf-8"?>
+<p:sld xmlns:a="http://schemas.openxmlformats.org/drawingml/2006/main" xmlns:p="http://schemas.openxmlformats.org/presentationml/2006/main" xmlns:r="http://schemas.openxmlformats.org/officeDocument/2006/relationships">
+  <p:cSld>
+    <p:bg>
+      <p:bgPr>
+        <a:solidFill>
+          <a:srgbClr val="FFFFFF"/>
+        </a:solidFill>
+        <a:effectLst/>
+      </p:bgPr>
+    </p:bg>
+    <p:spTree>
+      <p:nvGrpSpPr>
+        <p:cNvPr id="1" name=""/>
+        <p:cNvGrpSpPr/>
+        <p:nvPr/>
+      </p:nvGrpSpPr>
+      <p:grpSpPr/>
+      <p:sp>
+        <p:nvSpPr>
+          <p:cNvPr id="2" name="TextBox 1"/>
+          <p:cNvSpPr txBox="1"/>
+          <p:nvPr/>
+        </p:nvSpPr>
+        <p:spPr>
+          <a:xfrm>
+            <a:off x="713232" y="384048"/>
+            <a:ext cx="7315200" cy="274320"/>
+          </a:xfrm>
+          <a:prstGeom prst="rect">
+            <a:avLst/>
+          </a:prstGeom>
+          <a:noFill/>
+        </p:spPr>
+        <p:txBody>
+          <a:bodyPr wrap="square">
+            <a:spAutoFit/>
+          </a:bodyPr>
+          <a:lstStyle/>
+          <a:p>
+            <a:pPr algn="l">
+              <a:lnSpc>
+                <a:spcPct val="100000"/>
+              </a:lnSpc>
+            </a:pPr>
+            <a:r>
+              <a:rPr sz="1000" b="1">
+                <a:solidFill>
+                  <a:srgbClr val="5A6B69"/>
+                </a:solidFill>
+                <a:latin typeface="Segoe UI"/>
+              </a:rPr>
+              <a:t>DELPHI · ScienceClaw 2026</a:t>
+            </a:r>
+          </a:p>
+        </p:txBody>
+      </p:sp>
+      <p:sp>
+        <p:nvSpPr>
+          <p:cNvPr id="3" name="Rounded Rectangle 2"/>
+          <p:cNvSpPr/>
+          <p:nvPr/>
+        </p:nvSpPr>
+        <p:spPr>
+          <a:xfrm>
+            <a:off x="8826703" y="329184"/>
+            <a:ext cx="2651760" cy="310896"/>
+          </a:xfrm>
+          <a:prstGeom prst="roundRect">
+            <a:avLst/>
+          </a:prstGeom>
+          <a:solidFill>
+            <a:srgbClr val="FFFFFF"/>
+          </a:solidFill>
+          <a:ln w="12700">
+            <a:solidFill>
+              <a:srgbClr val="1BAF7A"/>
+            </a:solidFill>
+          </a:ln>
+          <a:effectLst/>
+        </p:spPr>
+        <p:style>
+          <a:lnRef idx="1">
+            <a:schemeClr val="accent1"/>
+          </a:lnRef>
+          <a:fillRef idx="3">
+            <a:schemeClr val="accent1"/>
+          </a:fillRef>
+          <a:effectRef idx="2">
+            <a:schemeClr val="accent1"/>
+          </a:effectRef>
+          <a:fontRef idx="minor">
+            <a:schemeClr val="lt1"/>
+          </a:fontRef>
+        </p:style>
+        <p:txBody>
+          <a:bodyPr rtlCol="0" anchor="ctr"/>
+          <a:lstStyle/>
+          <a:p>
+            <a:pPr algn="ctr"/>
+            <a:r>
+              <a:rPr sz="900" b="1">
+                <a:solidFill>
+                  <a:srgbClr val="1BAF7A"/>
+                </a:solidFill>
+              </a:rPr>
+              <a:t>EVIDENCE IN HAND</a:t>
+            </a:r>
+          </a:p>
+        </p:txBody>
+      </p:sp>
+      <p:sp>
+        <p:nvSpPr>
+          <p:cNvPr id="4" name="TextBox 3"/>
+          <p:cNvSpPr txBox="1"/>
+          <p:nvPr/>
+        </p:nvSpPr>
+        <p:spPr>
+          <a:xfrm>
+            <a:off x="713232" y="868680"/>
+            <a:ext cx="10765231" cy="1371600"/>
+          </a:xfrm>
+          <a:prstGeom prst="rect">
+            <a:avLst/>
+          </a:prstGeom>
+          <a:noFill/>
+        </p:spPr>
+        <p:txBody>
+          <a:bodyPr wrap="square">
+            <a:spAutoFit/>
+          </a:bodyPr>
+          <a:lstStyle/>
+          <a:p>
+            <a:pPr algn="l">
+              <a:lnSpc>
+                <a:spcPct val="92000"/>
+              </a:lnSpc>
+            </a:pPr>
+            <a:r>
+              <a:rPr sz="4000" b="1">
+                <a:solidFill>
+                  <a:srgbClr val="14201F"/>
+                </a:solidFill>
+                <a:latin typeface="Segoe UI"/>
+              </a:rPr>
+              <a:t>What we are not claiming.</a:t>
+            </a:r>
+          </a:p>
+        </p:txBody>
+      </p:sp>
+      <p:sp>
+        <p:nvSpPr>
+          <p:cNvPr id="5" name="TextBox 4"/>
+          <p:cNvSpPr txBox="1"/>
+          <p:nvPr/>
+        </p:nvSpPr>
+        <p:spPr>
+          <a:xfrm>
+            <a:off x="713232" y="2148840"/>
+            <a:ext cx="10765231" cy="731520"/>
+          </a:xfrm>
+          <a:prstGeom prst="rect">
+            <a:avLst/>
+          </a:prstGeom>
+          <a:noFill/>
+        </p:spPr>
+        <p:txBody>
+          <a:bodyPr wrap="square">
+            <a:spAutoFit/>
+          </a:bodyPr>
+          <a:lstStyle/>
+          <a:p>
+            <a:pPr algn="l">
+              <a:lnSpc>
+                <a:spcPct val="115000"/>
+              </a:lnSpc>
+            </a:pPr>
+            <a:r>
+              <a:rPr sz="1300" b="0">
+                <a:solidFill>
+                  <a:srgbClr val="14201F"/>
+                </a:solidFill>
+                <a:latin typeface="Segoe UI"/>
+              </a:rPr>
+              <a:t>—  No wet lab. Nothing here was measured at a bench by us; no new organism, protein or variant was made.</a:t>
+            </a:r>
+          </a:p>
+        </p:txBody>
+      </p:sp>
+      <p:sp>
+        <p:nvSpPr>
+          <p:cNvPr id="6" name="TextBox 5"/>
+          <p:cNvSpPr txBox="1"/>
+          <p:nvPr/>
+        </p:nvSpPr>
+        <p:spPr>
+          <a:xfrm>
+            <a:off x="713232" y="2898648"/>
+            <a:ext cx="10765231" cy="731520"/>
+          </a:xfrm>
+          <a:prstGeom prst="rect">
+            <a:avLst/>
+          </a:prstGeom>
+          <a:noFill/>
+        </p:spPr>
+        <p:txBody>
+          <a:bodyPr wrap="square">
+            <a:spAutoFit/>
+          </a:bodyPr>
+          <a:lstStyle/>
+          <a:p>
+            <a:pPr algn="l">
+              <a:lnSpc>
+                <a:spcPct val="115000"/>
+              </a:lnSpc>
+            </a:pPr>
+            <a:r>
+              <a:rPr sz="1300" b="0">
+                <a:solidFill>
+                  <a:srgbClr val="14201F"/>
+                </a:solidFill>
+                <a:latin typeface="Segoe UI"/>
+              </a:rPr>
+              <a:t>—  No proof about biology. The machine checked the reasoning from measurements to a safe route. That the measurements bracket the truth is assumed, and two replicates cannot justify it across 159,129 variants.</a:t>
+            </a:r>
+          </a:p>
+        </p:txBody>
+      </p:sp>
+      <p:sp>
+        <p:nvSpPr>
+          <p:cNvPr id="7" name="TextBox 6"/>
+          <p:cNvSpPr txBox="1"/>
+          <p:nvPr/>
+        </p:nvSpPr>
+        <p:spPr>
+          <a:xfrm>
+            <a:off x="713232" y="3648456"/>
+            <a:ext cx="10765231" cy="731520"/>
+          </a:xfrm>
+          <a:prstGeom prst="rect">
+            <a:avLst/>
+          </a:prstGeom>
+          <a:noFill/>
+        </p:spPr>
+        <p:txBody>
+          <a:bodyPr wrap="square">
+            <a:spAutoFit/>
+          </a:bodyPr>
+          <a:lstStyle/>
+          <a:p>
+            <a:pPr algn="l">
+              <a:lnSpc>
+                <a:spcPct val="115000"/>
+              </a:lnSpc>
+            </a:pPr>
+            <a:r>
+              <a:rPr sz="1300" b="0">
+                <a:solidFill>
+                  <a:srgbClr val="14201F"/>
+                </a:solidFill>
+                <a:latin typeface="Segoe UI"/>
+              </a:rPr>
+              <a:t>—  "Blocked" is not "impossible." It means unreachable in the measured four-position graph, never in biology.</a:t>
+            </a:r>
+          </a:p>
+        </p:txBody>
+      </p:sp>
+      <p:sp>
+        <p:nvSpPr>
+          <p:cNvPr id="8" name="TextBox 7"/>
+          <p:cNvSpPr txBox="1"/>
+          <p:nvPr/>
+        </p:nvSpPr>
+        <p:spPr>
+          <a:xfrm>
+            <a:off x="713232" y="4398264"/>
+            <a:ext cx="10765231" cy="731520"/>
+          </a:xfrm>
+          <a:prstGeom prst="rect">
+            <a:avLst/>
+          </a:prstGeom>
+          <a:noFill/>
+        </p:spPr>
+        <p:txBody>
+          <a:bodyPr wrap="square">
+            <a:spAutoFit/>
+          </a:bodyPr>
+          <a:lstStyle/>
+          <a:p>
+            <a:pPr algn="l">
+              <a:lnSpc>
+                <a:spcPct val="115000"/>
+              </a:lnSpc>
+            </a:pPr>
+            <a:r>
+              <a:rPr sz="1300" b="0">
+                <a:solidFill>
+                  <a:srgbClr val="14201F"/>
+                </a:solidFill>
+                <a:latin typeface="Segoe UI"/>
+              </a:rPr>
+              <a:t>—  The publications are unsigned drafts. Valid, unpublished, and described as drafts.</a:t>
+            </a:r>
+          </a:p>
+        </p:txBody>
+      </p:sp>
+      <p:sp>
+        <p:nvSpPr>
+          <p:cNvPr id="9" name="TextBox 8"/>
+          <p:cNvSpPr txBox="1"/>
+          <p:nvPr/>
+        </p:nvSpPr>
+        <p:spPr>
+          <a:xfrm>
+            <a:off x="713232" y="5148072"/>
+            <a:ext cx="10765231" cy="731520"/>
+          </a:xfrm>
+          <a:prstGeom prst="rect">
+            <a:avLst/>
+          </a:prstGeom>
+          <a:noFill/>
+        </p:spPr>
+        <p:txBody>
+          <a:bodyPr wrap="square">
+            <a:spAutoFit/>
+          </a:bodyPr>
+          <a:lstStyle/>
+          <a:p>
+            <a:pPr algn="l">
+              <a:lnSpc>
+                <a:spcPct val="115000"/>
+              </a:lnSpc>
+            </a:pPr>
+            <a:r>
+              <a:rPr sz="1300" b="0">
+                <a:solidFill>
+                  <a:srgbClr val="14201F"/>
+                </a:solidFill>
+                <a:latin typeface="Segoe UI"/>
+              </a:rPr>
+              <a:t>—  4 of 5 outside numbers reproduced exactly; the one we could not check, we said so rather than fill in.</a:t>
+            </a:r>
+          </a:p>
+        </p:txBody>
+      </p:sp>
+      <p:sp>
+        <p:nvSpPr>
+          <p:cNvPr id="10" name="TextBox 9"/>
+          <p:cNvSpPr txBox="1"/>
+          <p:nvPr/>
+        </p:nvSpPr>
+        <p:spPr>
+          <a:xfrm>
+            <a:off x="713232" y="5897880"/>
+            <a:ext cx="10765231" cy="731520"/>
+          </a:xfrm>
+          <a:prstGeom prst="rect">
+            <a:avLst/>
+          </a:prstGeom>
+          <a:noFill/>
+        </p:spPr>
+        <p:txBody>
+          <a:bodyPr wrap="square">
+            <a:spAutoFit/>
+          </a:bodyPr>
+          <a:lstStyle/>
+          <a:p>
+            <a:pPr algn="l">
+              <a:lnSpc>
+                <a:spcPct val="115000"/>
+              </a:lnSpc>
+            </a:pPr>
+            <a:r>
+              <a:rPr sz="1300" b="0">
+                <a:solidFill>
+                  <a:srgbClr val="14201F"/>
+                </a:solidFill>
+                <a:latin typeface="Segoe UI"/>
+              </a:rPr>
+              <a:t>—  4 of our own claims were corrected in one day — 3 found by our own checks, 1 by a collaborator's independent cross-check. Each was withdrawn or narrowed in public, as a record or a log entry, never as a silent edit.</a:t>
+            </a:r>
+          </a:p>
+        </p:txBody>
+      </p:sp>
+      <p:sp>
+        <p:nvSpPr>
+          <p:cNvPr id="11" name="TextBox 10"/>
+          <p:cNvSpPr txBox="1"/>
+          <p:nvPr/>
+        </p:nvSpPr>
+        <p:spPr>
+          <a:xfrm>
+            <a:off x="713232" y="6647688"/>
+            <a:ext cx="10765231" cy="731520"/>
+          </a:xfrm>
+          <a:prstGeom prst="rect">
+            <a:avLst/>
+          </a:prstGeom>
+          <a:noFill/>
+        </p:spPr>
+        <p:txBody>
+          <a:bodyPr wrap="square">
+            <a:spAutoFit/>
+          </a:bodyPr>
+          <a:lstStyle/>
+          <a:p>
+            <a:pPr algn="l">
+              <a:lnSpc>
+                <a:spcPct val="115000"/>
+              </a:lnSpc>
+            </a:pPr>
+            <a:r>
+              <a:rPr sz="1300" b="0">
+                <a:solidFill>
+                  <a:srgbClr val="14201F"/>
+                </a:solidFill>
+                <a:latin typeface="Segoe UI"/>
+              </a:rPr>
+              <a:t>—  We did not design an organism. The "designed" fish is Daane et al. 2021's published double heterozygote, and our pre-registered test of it came back unsupported. The apparatus is ours; the animal is not.</a:t>
+            </a:r>
+          </a:p>
+        </p:txBody>
+      </p:sp>
+      <p:sp>
+        <p:nvSpPr>
+          <p:cNvPr id="12" name="TextBox 11"/>
+          <p:cNvSpPr txBox="1"/>
+          <p:nvPr/>
+        </p:nvSpPr>
+        <p:spPr>
+          <a:xfrm>
+            <a:off x="713232" y="7397496"/>
+            <a:ext cx="10765231" cy="731520"/>
+          </a:xfrm>
+          <a:prstGeom prst="rect">
+            <a:avLst/>
+          </a:prstGeom>
+          <a:noFill/>
+        </p:spPr>
+        <p:txBody>
+          <a:bodyPr wrap="square">
+            <a:spAutoFit/>
+          </a:bodyPr>
+          <a:lstStyle/>
+          <a:p>
+            <a:pPr algn="l">
+              <a:lnSpc>
+                <a:spcPct val="115000"/>
+              </a:lnSpc>
+            </a:pPr>
+            <a:r>
+              <a:rPr sz="1300" b="0">
+                <a:solidFill>
+                  <a:srgbClr val="14201F"/>
+                </a:solidFill>
+                <a:latin typeface="Segoe UI"/>
+              </a:rPr>
+              <a:t>—  Validation on unseen data ran, and returned nothing. A clade was frozen as a holdout before the tests were built; 3 completed results were examined against it and 3 came back inconclusive. The 2 that state a reason were stopped by the builders' own pre-registered minimum sample size, not by a verdict we disliked. An exam that cannot reach a verdict is reported as one that cannot.</a:t>
+            </a:r>
+          </a:p>
+        </p:txBody>
+      </p:sp>
+      <p:sp>
+        <p:nvSpPr>
+          <p:cNvPr id="13" name="TextBox 12"/>
+          <p:cNvSpPr txBox="1"/>
+          <p:nvPr/>
+        </p:nvSpPr>
+        <p:spPr>
+          <a:xfrm>
+            <a:off x="713232" y="5623560"/>
+            <a:ext cx="10765231" cy="914400"/>
+          </a:xfrm>
+          <a:prstGeom prst="rect">
+            <a:avLst/>
+          </a:prstGeom>
+          <a:noFill/>
+        </p:spPr>
+        <p:txBody>
+          <a:bodyPr wrap="square">
+            <a:spAutoFit/>
+          </a:bodyPr>
+          <a:lstStyle/>
+          <a:p>
+            <a:pPr algn="l">
+              <a:lnSpc>
+                <a:spcPct val="115000"/>
+              </a:lnSpc>
+            </a:pPr>
+            <a:r>
+              <a:rPr sz="1200" b="0">
+                <a:solidFill>
+                  <a:srgbClr val="5A6B69"/>
+                </a:solidFill>
+                <a:latin typeface="Segoe UI"/>
+              </a:rPr>
+              <a:t>Every one of these is on the public dashboard too, next to the result it limits.</a:t>
+            </a:r>
+          </a:p>
+        </p:txBody>
+      </p:sp>
+    </p:spTree>
+  </p:cSld>
+  <p:clrMapOvr>
+    <a:masterClrMapping/>
+  </p:clrMapOvr>
+</p:sld>
+</file>
+
+<file path=ppt/slides/slide25.xml><?xml version="1.0" encoding="utf-8"?>
 <p:sld xmlns:a="http://schemas.openxmlformats.org/drawingml/2006/main" xmlns:p="http://schemas.openxmlformats.org/presentationml/2006/main" xmlns:r="http://schemas.openxmlformats.org/officeDocument/2006/relationships">
   <p:cSld>
     <p:bg>

</xml_diff>

<commit_message>
lean: lawset 1.3.0 records the depth cap as contested (8,336 m snailfish, proved contradictory in Lean); clean mutation rerun 57/57; constants audit; worked examples
- lean/registry/lean/P3bContested.lean: the depth-cap hypothesis plus a teleost at 8,336 m proves False
  (and 8,100 m does not), so perturb-depth-cap is contested (amber), the theorem kept under its hypothesis
- mutations.json: 57/57 mutants rejected, 18/18 controls, allAsExpected, after an earlier run was
  contaminated by concurrent lake builds
- sim-engine/scenarios/CONSTANTS-AUDIT.*: 388 constants, 258 confirmed, 6 corrected, 120 design-choice,
  3 unsourceable, 1 unverified; tooling in sim-engine/audit/
- sim-engine/examples/: six reproducible walkthroughs (text to design, impossible spec, current timecourse,
  altitude, predator, codesign session) that double as regression tests (run-all.mjs)

Co-Authored-By: Claude Opus 5.5 <noreply@anthropic.com>
</commit_message>
<xml_diff>
--- a/dashboard/public/deck/delphi-pitch.pptx
+++ b/dashboard/public/deck/delphi-pitch.pptx
@@ -1249,7 +1249,7 @@
               <c:strCache>
                 <c:ptCount val="1"/>
                 <c:pt idx="0">
-                  <c:v>22 pass</c:v>
+                  <c:v>21 pass (pre-registered: 19)</c:v>
                 </c:pt>
               </c:strCache>
             </c:strRef>
@@ -1291,7 +1291,7 @@
                 <c:formatCode>General</c:formatCode>
                 <c:ptCount val="4"/>
                 <c:pt idx="0">
-                  <c:v>11</c:v>
+                  <c:v>10</c:v>
                 </c:pt>
                 <c:pt idx="1">
                   <c:v>4</c:v>
@@ -1315,7 +1315,7 @@
               <c:strCache>
                 <c:ptCount val="1"/>
                 <c:pt idx="0">
-                  <c:v>8 circular: read the answer back</c:v>
+                  <c:v>7 circular: read the answer back (pre-registered: 6)</c:v>
                 </c:pt>
               </c:strCache>
             </c:strRef>
@@ -1357,7 +1357,7 @@
                 <c:formatCode>General</c:formatCode>
                 <c:ptCount val="4"/>
                 <c:pt idx="3">
-                  <c:v>8</c:v>
+                  <c:v>7</c:v>
                 </c:pt>
               </c:numCache>
             </c:numRef>
@@ -11408,7 +11408,7 @@
                 </a:solidFill>
                 <a:latin typeface="Segoe UI"/>
               </a:rPr>
-              <a:t>Typed: “a zebrafish that glides at least 5 m from 1 m height and survives 10 °C to 30 °C as an adult”. Read into 3 criteria, valid against the engine; every default it assumed is listed. Real page, real engine (engine/ (sim-engine: organism.mjs, state.mjs, 12 scenarios, data bundle 2026-11-01T02:57).); screenshot 2026-11-01T02:58:14.064Z, sha256 d25e671ed14e4cfb…</a:t>
+              <a:t>Typed: “a zebrafish that glides at least 5 m from 1 m height and survives 10 °C to 30 °C as an adult”. Read into 3 criteria, valid against the engine; every default it assumed is listed. Real page, real engine (engine/ (sim-engine: organism.mjs, state.mjs, 12 scenarios, data bundle 2026-11-01T03:05).); screenshot 2026-11-01T03:06:39.330Z, sha256 b935b1107a6d7724…</a:t>
             </a:r>
           </a:p>
         </p:txBody>
@@ -12851,7 +12851,7 @@
                 </a:solidFill>
                 <a:latin typeface="Segoe UI"/>
               </a:rPr>
-              <a:t>Law set 1.2.0 pins 52 laws, each with its version, a content hash over what it says, the Lean module and theorem, and the commit and statement hash it was checked at. Promotion to accepted is never automated. 4 further candidates were mined from the project's own sourced data.</a:t>
+              <a:t>Law set 1.3.0 pins 52 laws, each with its version, a content hash over what it says, the Lean module and theorem, and the commit and statement hash it was checked at. Promotion to accepted is never automated. 4 further candidates were mined from the project's own sourced data.</a:t>
             </a:r>
           </a:p>
         </p:txBody>
@@ -12890,7 +12890,7 @@
                 </a:solidFill>
                 <a:latin typeface="Segoe UI"/>
               </a:rPr>
-              <a:t>Served three ways from one loader: the hosted delphisci MCP server 0.3.0 (lean_laws_list, lean_law_get, lean_lawset_get, lean_check, lean_verify); the CLI and local sim-engine; and a static JSON mirror at /api/lean/, currently serving law set 1.2.0 (52 laws).</a:t>
+              <a:t>Served three ways from one loader: the delphisci MCP server 0.3.0 (lean_laws_list, lean_law_get, lean_lawset_get, lean_check, lean_verify; the hosted copy has them only once this change is merged and redeployed, so check its tools/list first); the CLI and local sim-engine; and a static JSON mirror at /api/lean/, currently serving law set 1.3.0 (52 laws).</a:t>
             </a:r>
           </a:p>
         </p:txBody>
@@ -13118,7 +13118,7 @@
         </p:nvGraphicFramePr>
         <p:xfrm>
           <a:off x="713232" y="1965960"/>
-          <a:ext cx="10765231" cy="2148840"/>
+          <a:ext cx="10765231" cy="1920240"/>
         </p:xfrm>
         <a:graphic>
           <a:graphicData uri="http://schemas.openxmlformats.org/drawingml/2006/chart">
@@ -13134,7 +13134,124 @@
         </p:nvSpPr>
         <p:spPr>
           <a:xfrm>
+            <a:off x="713232" y="4023360"/>
+            <a:ext cx="9210751" cy="310896"/>
+          </a:xfrm>
+          <a:prstGeom prst="rect">
+            <a:avLst/>
+          </a:prstGeom>
+          <a:noFill/>
+        </p:spPr>
+        <p:txBody>
+          <a:bodyPr wrap="square">
+            <a:spAutoFit/>
+          </a:bodyPr>
+          <a:lstStyle/>
+          <a:p>
+            <a:pPr algn="l">
+              <a:lnSpc>
+                <a:spcPct val="100000"/>
+              </a:lnSpc>
+            </a:pPr>
+            <a:r>
+              <a:rPr sz="1400" b="1">
+                <a:solidFill>
+                  <a:srgbClr val="14201F"/>
+                </a:solidFill>
+                <a:latin typeface="Segoe UI"/>
+              </a:rPr>
+              <a:t>7 “passes” read the answer back</a:t>
+            </a:r>
+          </a:p>
+        </p:txBody>
+      </p:sp>
+      <p:sp>
+        <p:nvSpPr>
+          <p:cNvPr id="7" name="TextBox 6"/>
+          <p:cNvSpPr txBox="1"/>
+          <p:nvPr/>
+        </p:nvSpPr>
+        <p:spPr>
+          <a:xfrm>
+            <a:off x="10198303" y="4023360"/>
+            <a:ext cx="1280160" cy="310896"/>
+          </a:xfrm>
+          <a:prstGeom prst="rect">
+            <a:avLst/>
+          </a:prstGeom>
+          <a:noFill/>
+        </p:spPr>
+        <p:txBody>
+          <a:bodyPr wrap="square">
+            <a:spAutoFit/>
+          </a:bodyPr>
+          <a:lstStyle/>
+          <a:p>
+            <a:pPr algn="r">
+              <a:lnSpc>
+                <a:spcPct val="100000"/>
+              </a:lnSpc>
+            </a:pPr>
+            <a:r>
+              <a:rPr sz="1400" b="1">
+                <a:solidFill>
+                  <a:srgbClr val="6250D6"/>
+                </a:solidFill>
+                <a:latin typeface="Segoe UI"/>
+              </a:rPr>
+              <a:t>circular</a:t>
+            </a:r>
+          </a:p>
+        </p:txBody>
+      </p:sp>
+      <p:sp>
+        <p:nvSpPr>
+          <p:cNvPr id="8" name="TextBox 7"/>
+          <p:cNvSpPr txBox="1"/>
+          <p:nvPr/>
+        </p:nvSpPr>
+        <p:spPr>
+          <a:xfrm>
             <a:off x="713232" y="4297680"/>
+            <a:ext cx="10399471" cy="329184"/>
+          </a:xfrm>
+          <a:prstGeom prst="rect">
+            <a:avLst/>
+          </a:prstGeom>
+          <a:noFill/>
+        </p:spPr>
+        <p:txBody>
+          <a:bodyPr wrap="square">
+            <a:spAutoFit/>
+          </a:bodyPr>
+          <a:lstStyle/>
+          <a:p>
+            <a:pPr algn="l">
+              <a:lnSpc>
+                <a:spcPct val="112000"/>
+              </a:lnSpc>
+            </a:pPr>
+            <a:r>
+              <a:rPr sz="1000" b="0">
+                <a:solidFill>
+                  <a:srgbClr val="5A6B69"/>
+                </a:solidFill>
+                <a:latin typeface="Segoe UI"/>
+              </a:rPr>
+              <a:t>W1, W2, W3, W5, W6, W7, W9: in band only because the module is calibrated to, interpolates, or quotes the paper it is scored against. Scored circular, never counted as a pass.</a:t>
+            </a:r>
+          </a:p>
+        </p:txBody>
+      </p:sp>
+      <p:sp>
+        <p:nvSpPr>
+          <p:cNvPr id="9" name="TextBox 8"/>
+          <p:cNvSpPr txBox="1"/>
+          <p:nvPr/>
+        </p:nvSpPr>
+        <p:spPr>
+          <a:xfrm>
+            <a:off x="713232" y="4590288"/>
             <a:ext cx="9210751" cy="310896"/>
           </a:xfrm>
           <a:prstGeom prst="rect">
@@ -13160,20 +13277,20 @@
                 </a:solidFill>
                 <a:latin typeface="Segoe UI"/>
               </a:rPr>
-              <a:t>8 “passes” were the studio reading its own sources back</a:t>
-            </a:r>
-          </a:p>
-        </p:txBody>
-      </p:sp>
-      <p:sp>
-        <p:nvSpPr>
-          <p:cNvPr id="7" name="TextBox 6"/>
-          <p:cNvSpPr txBox="1"/>
-          <p:nvPr/>
-        </p:nvSpPr>
-        <p:spPr>
-          <a:xfrm>
-            <a:off x="10198303" y="4297680"/>
+              <a:t>3 verdicts changed by amendments written after the results</a:t>
+            </a:r>
+          </a:p>
+        </p:txBody>
+      </p:sp>
+      <p:sp>
+        <p:nvSpPr>
+          <p:cNvPr id="10" name="TextBox 9"/>
+          <p:cNvSpPr txBox="1"/>
+          <p:nvPr/>
+        </p:nvSpPr>
+        <p:spPr>
+          <a:xfrm>
+            <a:off x="10198303" y="4590288"/>
             <a:ext cx="1280160" cy="310896"/>
           </a:xfrm>
           <a:prstGeom prst="rect">
@@ -13195,25 +13312,25 @@
             <a:r>
               <a:rPr sz="1400" b="1">
                 <a:solidFill>
-                  <a:srgbClr val="6250D6"/>
-                </a:solidFill>
-                <a:latin typeface="Segoe UI"/>
-              </a:rPr>
-              <a:t>circular</a:t>
-            </a:r>
-          </a:p>
-        </p:txBody>
-      </p:sp>
-      <p:sp>
-        <p:nvSpPr>
-          <p:cNvPr id="8" name="TextBox 7"/>
-          <p:cNvSpPr txBox="1"/>
-          <p:nvPr/>
-        </p:nvSpPr>
-        <p:spPr>
-          <a:xfrm>
-            <a:off x="713232" y="4572000"/>
-            <a:ext cx="10399471" cy="274320"/>
+                  <a:srgbClr val="EB6834"/>
+                </a:solidFill>
+                <a:latin typeface="Segoe UI"/>
+              </a:rPr>
+              <a:t>3</a:t>
+            </a:r>
+          </a:p>
+        </p:txBody>
+      </p:sp>
+      <p:sp>
+        <p:nvSpPr>
+          <p:cNvPr id="11" name="TextBox 10"/>
+          <p:cNvSpPr txBox="1"/>
+          <p:nvPr/>
+        </p:nvSpPr>
+        <p:spPr>
+          <a:xfrm>
+            <a:off x="713232" y="4864608"/>
+            <a:ext cx="10399471" cy="329184"/>
           </a:xfrm>
           <a:prstGeom prst="rect">
             <a:avLst/>
@@ -13238,20 +13355,20 @@
                 </a:solidFill>
                 <a:latin typeface="Segoe UI"/>
               </a:rPr>
-              <a:t>W1, W2, W3, W5, W6, W7, W8, W9: in band only because the module interpolates, or quotes, the paper it is scored against. Reclassified after the results in a labelled amendment (A1).</a:t>
-            </a:r>
-          </a:p>
-        </p:txBody>
-      </p:sp>
-      <p:sp>
-        <p:nvSpPr>
-          <p:cNvPr id="9" name="TextBox 8"/>
-          <p:cNvSpPr txBox="1"/>
-          <p:nvPr/>
-        </p:nvSpPr>
-        <p:spPr>
-          <a:xfrm>
-            <a:off x="713232" y="5989320"/>
+              <a:t>W1 pass-rests-on-assumed → circular (A1); W11 fail → pass (A2); N5 fail → pass (A3). Both verdicts kept side by side; the pre-registration file is unchanged.</a:t>
+            </a:r>
+          </a:p>
+        </p:txBody>
+      </p:sp>
+      <p:sp>
+        <p:nvSpPr>
+          <p:cNvPr id="12" name="TextBox 11"/>
+          <p:cNvSpPr txBox="1"/>
+          <p:nvPr/>
+        </p:nvSpPr>
+        <p:spPr>
+          <a:xfrm>
+            <a:off x="713232" y="5833872"/>
             <a:ext cx="10765231" cy="914400"/>
           </a:xfrm>
           <a:prstGeom prst="rect">
@@ -13277,7 +13394,7 @@
                 </a:solidFill>
                 <a:latin typeface="Segoe UI"/>
               </a:rPr>
-              <a:t>Tests fixed before any scenario module existed; the pre-registration still hashes to f2523da8529b998e…. Written by an agent that built none of the studio. Harness self-test: 20 of 20 checks fail on a planted bad input. Every negative, law and optimizer control held.  Read from sim-engine/validation/studio-results.json, run 2026-11-01T03:02:07.484Z.</a:t>
+              <a:t>Tests fixed before any scenario module existed; the pre-registration still hashes to f2523da8529b998e…. Written by an agent that built none of the studio. Harness self-test: 20 of 20 checks fail on a planted bad input. Every negative, law and optimizer control held; N5 only under a post-results amendment (A3).  Read from sim-engine/validation/studio-results.json, run 2026-11-01T03:06:37.022Z.</a:t>
             </a:r>
           </a:p>
         </p:txBody>

</xml_diff>

<commit_message>
correction #6: the aerobic ceiling used a borrowed snapper cardiac output far below measured zebrafish oxygen uptake; flight shortfall is ~10-29x (16x against E3 2.0.0), not 29-38x
Found because a real zebrafish broke our own aerobic bound in the studio: flat-plate drag power (a lower
bound) exceeded the Fick ceiling (an upper bound) over the top 18% of its measured sustained speeds.
Measured zebrafish MO2 at Ucrit (Palstra 2010) is 2.8x that ceiling; even measured resting rates exceed it.

Versioned: E3 2.0.0 (envelope 0.0458 -> 0.0833 W, proved weaker than v1 in Lean), perturb-current 1.1.0
(P2b scoped below ~0.8 Ucrit), fick-principle 1.1.0 (needs a taxon-appropriate MO2max or Q); old versions
archived, lawsets <= 1.5.0 still reproduce their old verdicts. Lawset 1.6.0. Powered flight still ruled
out by an order of magnitude. Zebrafish now in fresh water.

Co-Authored-By: Claude Opus 5 <noreply@anthropic.com>
</commit_message>
<xml_diff>
--- a/dashboard/public/deck/delphi-pitch.pptx
+++ b/dashboard/public/deck/delphi-pitch.pptx
@@ -1291,13 +1291,13 @@
                 <c:formatCode>General</c:formatCode>
                 <c:ptCount val="4"/>
                 <c:pt idx="0">
-                  <c:v>10</c:v>
+                  <c:v>11</c:v>
                 </c:pt>
                 <c:pt idx="1">
                   <c:v>4</c:v>
                 </c:pt>
                 <c:pt idx="2">
-                  <c:v>5</c:v>
+                  <c:v>4</c:v>
                 </c:pt>
                 <c:pt idx="3">
                   <c:v>2</c:v>
@@ -1315,7 +1315,64 @@
               <c:strCache>
                 <c:ptCount val="1"/>
                 <c:pt idx="0">
-                  <c:v>7 circular: read the answer back (pre-registered: 6)</c:v>
+                  <c:v>1 pass, rests on an assumed input (pre-registered: 3)</c:v>
+                </c:pt>
+              </c:strCache>
+            </c:strRef>
+          </c:tx>
+          <c:spPr>
+            <a:solidFill>
+              <a:srgbClr val="8FD6BC"/>
+            </a:solidFill>
+            <a:ln w="19050">
+              <a:solidFill>
+                <a:srgbClr val="FFFFFF"/>
+              </a:solidFill>
+            </a:ln>
+          </c:spPr>
+          <c:cat>
+            <c:strRef>
+              <c:f>Sheet1!$A$2:$A$5</c:f>
+              <c:strCache>
+                <c:ptCount val="4"/>
+                <c:pt idx="0">
+                  <c:v>Contract and determinism, per scenario (11)</c:v>
+                </c:pt>
+                <c:pt idx="1">
+                  <c:v>Optimizer and parser controls (4)</c:v>
+                </c:pt>
+                <c:pt idx="2">
+                  <c:v>Negative and law controls (5)</c:v>
+                </c:pt>
+                <c:pt idx="3">
+                  <c:v>Wild-type predictions (11)</c:v>
+                </c:pt>
+              </c:strCache>
+            </c:strRef>
+          </c:cat>
+          <c:val>
+            <c:numRef>
+              <c:f>Sheet1!$C$2:$C$5</c:f>
+              <c:numCache>
+                <c:formatCode>General</c:formatCode>
+                <c:ptCount val="4"/>
+                <c:pt idx="3">
+                  <c:v>1</c:v>
+                </c:pt>
+              </c:numCache>
+            </c:numRef>
+          </c:val>
+        </c:ser>
+        <c:ser>
+          <c:idx val="2"/>
+          <c:order val="2"/>
+          <c:tx>
+            <c:strRef>
+              <c:f>Sheet1!$D$1</c:f>
+              <c:strCache>
+                <c:ptCount val="1"/>
+                <c:pt idx="0">
+                  <c:v>7 circular: read the answer back (pre-registered: 5)</c:v>
                 </c:pt>
               </c:strCache>
             </c:strRef>
@@ -1352,7 +1409,7 @@
           </c:cat>
           <c:val>
             <c:numRef>
-              <c:f>Sheet1!$C$2:$C$5</c:f>
+              <c:f>Sheet1!$D$2:$D$5</c:f>
               <c:numCache>
                 <c:formatCode>General</c:formatCode>
                 <c:ptCount val="4"/>
@@ -1364,11 +1421,68 @@
           </c:val>
         </c:ser>
         <c:ser>
-          <c:idx val="2"/>
-          <c:order val="2"/>
+          <c:idx val="3"/>
+          <c:order val="3"/>
           <c:tx>
             <c:strRef>
-              <c:f>Sheet1!$D$1</c:f>
+              <c:f>Sheet1!$E$1</c:f>
+              <c:strCache>
+                <c:ptCount val="1"/>
+                <c:pt idx="0">
+                  <c:v>1 fail (pre-registered: 3)</c:v>
+                </c:pt>
+              </c:strCache>
+            </c:strRef>
+          </c:tx>
+          <c:spPr>
+            <a:solidFill>
+              <a:srgbClr val="EB6834"/>
+            </a:solidFill>
+            <a:ln w="19050">
+              <a:solidFill>
+                <a:srgbClr val="FFFFFF"/>
+              </a:solidFill>
+            </a:ln>
+          </c:spPr>
+          <c:cat>
+            <c:strRef>
+              <c:f>Sheet1!$A$2:$A$5</c:f>
+              <c:strCache>
+                <c:ptCount val="4"/>
+                <c:pt idx="0">
+                  <c:v>Contract and determinism, per scenario (11)</c:v>
+                </c:pt>
+                <c:pt idx="1">
+                  <c:v>Optimizer and parser controls (4)</c:v>
+                </c:pt>
+                <c:pt idx="2">
+                  <c:v>Negative and law controls (5)</c:v>
+                </c:pt>
+                <c:pt idx="3">
+                  <c:v>Wild-type predictions (11)</c:v>
+                </c:pt>
+              </c:strCache>
+            </c:strRef>
+          </c:cat>
+          <c:val>
+            <c:numRef>
+              <c:f>Sheet1!$E$2:$E$5</c:f>
+              <c:numCache>
+                <c:formatCode>General</c:formatCode>
+                <c:ptCount val="4"/>
+                <c:pt idx="2">
+                  <c:v>1</c:v>
+                </c:pt>
+              </c:numCache>
+            </c:numRef>
+          </c:val>
+        </c:ser>
+        <c:ser>
+          <c:idx val="4"/>
+          <c:order val="4"/>
+          <c:tx>
+            <c:strRef>
+              <c:f>Sheet1!$F$1</c:f>
               <c:strCache>
                 <c:ptCount val="1"/>
                 <c:pt idx="0">
@@ -1409,7 +1523,7 @@
           </c:cat>
           <c:val>
             <c:numRef>
-              <c:f>Sheet1!$D$2:$D$5</c:f>
+              <c:f>Sheet1!$F$2:$F$5</c:f>
               <c:numCache>
                 <c:formatCode>General</c:formatCode>
                 <c:ptCount val="4"/>
@@ -8871,7 +8985,7 @@
                 </a:solidFill>
                 <a:latin typeface="Segoe UI"/>
               </a:rPr>
-              <a:t>38x  /  29x</a:t>
+              <a:t>10-30x</a:t>
             </a:r>
           </a:p>
         </p:txBody>
@@ -8910,7 +9024,7 @@
                 </a:solidFill>
                 <a:latin typeface="Segoe UI"/>
               </a:rPr>
-              <a:t>short on those proxies, and on the widest combination the measured record allows — both checked by the Lean kernel</a:t>
+              <a:t>short (central about 20x; 16x on the widened envelope, 38x with the original snapper-based proxies), checked by the Lean kernel</a:t>
             </a:r>
           </a:p>
         </p:txBody>
@@ -9201,7 +9315,7 @@
                 </a:solidFill>
                 <a:latin typeface="Segoe UI"/>
               </a:rPr>
-              <a:t>TWO CEILINGS, AND THE SMALLER MULTIPLIER IS THE STRONGER CLAIM. 0.0357 W is the product of the four proxy values this candidate commits to, so 38x rules flight out for THAT ONE PARAMETERISATION. 0.0458 W instead takes the MAXIMUM of each measured teleost range (eta &lt;= 0.15, E &lt;= 19.35 J/ml, Q &lt;= 0.075 ml/s, Ca &lt;= 0.21 ml/ml), so it is necessarily the larger ceiling and the smaller multiplier — and 29x rules it out for EVERY animal the measured record allows. Neither supersedes the other: different quantities, both kernel-checked. Reject it and C14 still rules, but only on the particular proxies a candidate commits, not on every teleost.</a:t>
+              <a:t>TWO CEILINGS, AND A CORRECTION. 0.0357 W is the product of the four proxy values this candidate commits to (a snapper cardiac output), so 38x rules flight out for THAT ONE PARAMETERISATION. 0.0833 W is the widened envelope (η ≤ 0.23, E ≤ 19.35 J/ml, o2Delivery ≤ 0.0187 ml O2/s), 16x short. Corrected 2026-11-01: the proxies borrowed a snapper cardiac output, and a measured zebrafish at U_crit takes up 2.8× the O2 that ceiling allows (Palstra et al. 2010, PLoS One 5:e14483). With a zebrafish-derived O2 delivery and a skeletal-muscle efficiency the shortfall is about 10 to 30× (central about 20×), not 29 to 38×; 38× is what the original snapper-based proxies give. Sustained aerobic flight is still ruled out by an order of magnitude. Reject it and C14 still rules, but only on the particular proxies a candidate commits.</a:t>
             </a:r>
           </a:p>
         </p:txBody>
@@ -9240,7 +9354,7 @@
                 </a:solidFill>
                 <a:latin typeface="Segoe UI"/>
               </a:rPr>
-              <a:t>What it rests on: Fick's principle, aerobic power rather than burst power, and teleost proxy values — no flying-fish physiology exists, so the proxies are what the elimination rests on. What it does NOT bound: gliding (a flying fish is a glider), and short burst flight. 3 of 3 candidates eliminated by theorems the compiler accepted; 41 other constraints on the same candidates could not be fired at all, for want of an input. A proof about a model, not a fact about a fish.</a:t>
+              <a:t>What it rests on: Fick's principle, aerobic power rather than burst power, and teleost proxy values — no flying-fish physiology exists, so the proxies are what the elimination rests on. What it does NOT bound: gliding (a flying fish is a glider), and short burst flight. 3 of 3 candidates eliminated by theorems the compiler accepted; 50 other constraints on the same candidates could not be fired at all, for want of an input. A proof about a model, not a fact about a fish.</a:t>
             </a:r>
           </a:p>
         </p:txBody>
@@ -12220,7 +12334,7 @@
                 </a:solidFill>
                 <a:latin typeface="Segoe UI"/>
               </a:rPr>
-              <a:t>9</a:t>
+              <a:t>5</a:t>
             </a:r>
           </a:p>
         </p:txBody>
@@ -12259,7 +12373,7 @@
                 </a:solidFill>
                 <a:latin typeface="Segoe UI"/>
               </a:rPr>
-              <a:t>3 physical · 6 biological</a:t>
+              <a:t>1 physical · 4 biological</a:t>
             </a:r>
           </a:p>
           <a:p>
@@ -12399,7 +12513,7 @@
                 </a:solidFill>
                 <a:latin typeface="Segoe UI"/>
               </a:rPr>
-              <a:t>31</a:t>
+              <a:t>36</a:t>
             </a:r>
           </a:p>
         </p:txBody>
@@ -12438,7 +12552,7 @@
                 </a:solidFill>
                 <a:latin typeface="Segoe UI"/>
               </a:rPr>
-              <a:t>11 physical · 20 biological</a:t>
+              <a:t>13 physical · 23 biological</a:t>
             </a:r>
           </a:p>
           <a:p>
@@ -12851,7 +12965,7 @@
                 </a:solidFill>
                 <a:latin typeface="Segoe UI"/>
               </a:rPr>
-              <a:t>Law set 1.3.0 pins 52 laws, each with its version, a content hash over what it says, the Lean module and theorem, and the commit and statement hash it was checked at. Promotion to accepted is never automated. 4 further candidates were mined from the project's own sourced data.</a:t>
+              <a:t>Law set 1.6.0 pins 53 laws, each with its version, a content hash over what it says, the Lean module and theorem, and the commit and statement hash it was checked at. Promotion to accepted is never automated. 4 further candidates were mined from the project's own sourced data.</a:t>
             </a:r>
           </a:p>
         </p:txBody>
@@ -12890,7 +13004,7 @@
                 </a:solidFill>
                 <a:latin typeface="Segoe UI"/>
               </a:rPr>
-              <a:t>Served three ways from one loader: the delphisci MCP server 0.3.0 (lean_laws_list, lean_law_get, lean_lawset_get, lean_check, lean_verify; the hosted copy has them only once this change is merged and redeployed, so check its tools/list first); the CLI and local sim-engine; and a static JSON mirror at /api/lean/, currently serving law set 1.3.0 (52 laws).</a:t>
+              <a:t>Served three ways from one loader: the delphisci MCP server 0.6.0 (lean_laws_list, lean_law_get, lean_lawset_get, lean_check, lean_verify; the hosted copy has them only once this change is merged and redeployed, so check its tools/list first); the CLI and local sim-engine; and a static JSON mirror at /api/lean/, currently serving law set 1.6.0 (53 laws).</a:t>
             </a:r>
           </a:p>
         </p:txBody>
@@ -13160,7 +13274,7 @@
                 </a:solidFill>
                 <a:latin typeface="Segoe UI"/>
               </a:rPr>
-              <a:t>7 “passes” read the answer back</a:t>
+              <a:t>N2 · no fish survives at 9,000 or 10,000 m</a:t>
             </a:r>
           </a:p>
         </p:txBody>
@@ -13195,11 +13309,11 @@
             <a:r>
               <a:rPr sz="1400" b="1">
                 <a:solidFill>
-                  <a:srgbClr val="6250D6"/>
-                </a:solidFill>
-                <a:latin typeface="Segoe UI"/>
-              </a:rPr>
-              <a:t>circular</a:t>
+                  <a:srgbClr val="EB6834"/>
+                </a:solidFill>
+                <a:latin typeface="Segoe UI"/>
+              </a:rPr>
+              <a:t>fail</a:t>
             </a:r>
           </a:p>
         </p:txBody>
@@ -13238,7 +13352,7 @@
                 </a:solidFill>
                 <a:latin typeface="Segoe UI"/>
               </a:rPr>
-              <a:t>W1, W2, W3, W5, W6, W7, W9: in band only because the module is calibrated to, interpolates, or quotes the paper it is scored against. Scored circular, never counted as a pass.</a:t>
+              <a:t>6 organism/depth runs did not report death</a:t>
             </a:r>
           </a:p>
         </p:txBody>
@@ -13277,7 +13391,7 @@
                 </a:solidFill>
                 <a:latin typeface="Segoe UI"/>
               </a:rPr>
-              <a:t>3 verdicts changed by amendments written after the results</a:t>
+              <a:t>7 “passes” read the answer back</a:t>
             </a:r>
           </a:p>
         </p:txBody>
@@ -13312,11 +13426,11 @@
             <a:r>
               <a:rPr sz="1400" b="1">
                 <a:solidFill>
-                  <a:srgbClr val="EB6834"/>
-                </a:solidFill>
-                <a:latin typeface="Segoe UI"/>
-              </a:rPr>
-              <a:t>3</a:t>
+                  <a:srgbClr val="6250D6"/>
+                </a:solidFill>
+                <a:latin typeface="Segoe UI"/>
+              </a:rPr>
+              <a:t>circular</a:t>
             </a:r>
           </a:p>
         </p:txBody>
@@ -13355,7 +13469,7 @@
                 </a:solidFill>
                 <a:latin typeface="Segoe UI"/>
               </a:rPr>
-              <a:t>W1 pass-rests-on-assumed → circular (A1); W11 fail → pass (A2); N5 fail → pass (A3). Both verdicts kept side by side; the pre-registration file is unchanged.</a:t>
+              <a:t>W1, W2, W3, W5, W6, W7, W8: in band only because the module is calibrated to, interpolates, or quotes the paper it is scored against. Scored circular, never counted as a pass.</a:t>
             </a:r>
           </a:p>
         </p:txBody>
@@ -13363,6 +13477,123 @@
       <p:sp>
         <p:nvSpPr>
           <p:cNvPr id="12" name="TextBox 11"/>
+          <p:cNvSpPr txBox="1"/>
+          <p:nvPr/>
+        </p:nvSpPr>
+        <p:spPr>
+          <a:xfrm>
+            <a:off x="713232" y="5157216"/>
+            <a:ext cx="9210751" cy="310896"/>
+          </a:xfrm>
+          <a:prstGeom prst="rect">
+            <a:avLst/>
+          </a:prstGeom>
+          <a:noFill/>
+        </p:spPr>
+        <p:txBody>
+          <a:bodyPr wrap="square">
+            <a:spAutoFit/>
+          </a:bodyPr>
+          <a:lstStyle/>
+          <a:p>
+            <a:pPr algn="l">
+              <a:lnSpc>
+                <a:spcPct val="100000"/>
+              </a:lnSpc>
+            </a:pPr>
+            <a:r>
+              <a:rPr sz="1400" b="1">
+                <a:solidFill>
+                  <a:srgbClr val="14201F"/>
+                </a:solidFill>
+                <a:latin typeface="Segoe UI"/>
+              </a:rPr>
+              <a:t>4 verdicts changed by amendments written after the results</a:t>
+            </a:r>
+          </a:p>
+        </p:txBody>
+      </p:sp>
+      <p:sp>
+        <p:nvSpPr>
+          <p:cNvPr id="13" name="TextBox 12"/>
+          <p:cNvSpPr txBox="1"/>
+          <p:nvPr/>
+        </p:nvSpPr>
+        <p:spPr>
+          <a:xfrm>
+            <a:off x="10198303" y="5157216"/>
+            <a:ext cx="1280160" cy="310896"/>
+          </a:xfrm>
+          <a:prstGeom prst="rect">
+            <a:avLst/>
+          </a:prstGeom>
+          <a:noFill/>
+        </p:spPr>
+        <p:txBody>
+          <a:bodyPr wrap="square">
+            <a:spAutoFit/>
+          </a:bodyPr>
+          <a:lstStyle/>
+          <a:p>
+            <a:pPr algn="r">
+              <a:lnSpc>
+                <a:spcPct val="100000"/>
+              </a:lnSpc>
+            </a:pPr>
+            <a:r>
+              <a:rPr sz="1400" b="1">
+                <a:solidFill>
+                  <a:srgbClr val="EB6834"/>
+                </a:solidFill>
+                <a:latin typeface="Segoe UI"/>
+              </a:rPr>
+              <a:t>4</a:t>
+            </a:r>
+          </a:p>
+        </p:txBody>
+      </p:sp>
+      <p:sp>
+        <p:nvSpPr>
+          <p:cNvPr id="14" name="TextBox 13"/>
+          <p:cNvSpPr txBox="1"/>
+          <p:nvPr/>
+        </p:nvSpPr>
+        <p:spPr>
+          <a:xfrm>
+            <a:off x="713232" y="5431536"/>
+            <a:ext cx="10399471" cy="329184"/>
+          </a:xfrm>
+          <a:prstGeom prst="rect">
+            <a:avLst/>
+          </a:prstGeom>
+          <a:noFill/>
+        </p:spPr>
+        <p:txBody>
+          <a:bodyPr wrap="square">
+            <a:spAutoFit/>
+          </a:bodyPr>
+          <a:lstStyle/>
+          <a:p>
+            <a:pPr algn="l">
+              <a:lnSpc>
+                <a:spcPct val="112000"/>
+              </a:lnSpc>
+            </a:pPr>
+            <a:r>
+              <a:rPr sz="1000" b="0">
+                <a:solidFill>
+                  <a:srgbClr val="5A6B69"/>
+                </a:solidFill>
+                <a:latin typeface="Segoe UI"/>
+              </a:rPr>
+              <a:t>W1 pass-rests-on-assumed → circular (A1); W8 pass-rests-on-assumed → circular (A1); W11 fail → pass (A2); N5 fail → pass (A3). Both verdicts kept side by side; the pre-registration file is unchanged.</a:t>
+            </a:r>
+          </a:p>
+        </p:txBody>
+      </p:sp>
+      <p:sp>
+        <p:nvSpPr>
+          <p:cNvPr id="15" name="TextBox 14"/>
           <p:cNvSpPr txBox="1"/>
           <p:nvPr/>
         </p:nvSpPr>
@@ -13394,7 +13625,7 @@
                 </a:solidFill>
                 <a:latin typeface="Segoe UI"/>
               </a:rPr>
-              <a:t>Tests fixed before any scenario module existed; the pre-registration still hashes to f2523da8529b998e…. Written by an agent that built none of the studio. Harness self-test: 20 of 20 checks fail on a planted bad input. Every negative, law and optimizer control held; N5 only under a post-results amendment (A3).  Read from sim-engine/validation/studio-results.json, run 2026-11-01T03:06:37.022Z.</a:t>
+              <a:t>Tests fixed before any scenario module existed; the pre-registration still hashes to f2523da8529b998e…. Written by an agent that built none of the studio. Harness self-test: 20 of 20 checks fail on a planted bad input. Not every control held; N5 only under a post-results amendment (A3).  Read from sim-engine/validation/studio-results.json, run 2026-11-01T04:39:33.255Z.</a:t>
             </a:r>
           </a:p>
         </p:txBody>

</xml_diff>